<commit_message>
Removed zoom link from intro slides
</commit_message>
<xml_diff>
--- a/topics/other/slide_introduction_zoom.pptx
+++ b/topics/other/slide_introduction_zoom.pptx
@@ -5,7 +5,7 @@
     <p:sldMasterId id="2147483648" r:id="rId2"/>
     <p:sldMasterId id="2147483650" r:id="rId3"/>
     <p:sldMasterId id="2147483652" r:id="rId4"/>
-    <p:sldMasterId id="2147483657" r:id="rId5"/>
+    <p:sldMasterId id="2147483658" r:id="rId5"/>
   </p:sldMasterIdLst>
   <p:notesMasterIdLst>
     <p:notesMasterId r:id="rId6"/>
@@ -45,7 +45,7 @@
       </p:grpSpPr>
       <p:sp>
         <p:nvSpPr>
-          <p:cNvPr id="31" name="PlaceHolder 1"/>
+          <p:cNvPr id="36" name="PlaceHolder 1"/>
           <p:cNvSpPr>
             <a:spLocks noGrp="1"/>
           </p:cNvSpPr>
@@ -81,62 +81,7 @@
                 <a:uFillTx/>
                 <a:latin typeface="Arial"/>
               </a:rPr>
-              <a:t>Click </a:t>
-            </a:r>
-            <a:r>
-              <a:rPr lang="en-US" sz="4400" b="0" u="none" strike="noStrike">
-                <a:solidFill>
-                  <a:srgbClr val="000000"/>
-                </a:solidFill>
-                <a:effectLst/>
-                <a:uFillTx/>
-                <a:latin typeface="Arial"/>
-              </a:rPr>
-              <a:t>to </a:t>
-            </a:r>
-            <a:r>
-              <a:rPr lang="en-US" sz="4400" b="0" u="none" strike="noStrike">
-                <a:solidFill>
-                  <a:srgbClr val="000000"/>
-                </a:solidFill>
-                <a:effectLst/>
-                <a:uFillTx/>
-                <a:latin typeface="Arial"/>
-              </a:rPr>
-              <a:t>mov</a:t>
-            </a:r>
-            <a:r>
-              <a:rPr lang="en-US" sz="4400" b="0" u="none" strike="noStrike">
-                <a:solidFill>
-                  <a:srgbClr val="000000"/>
-                </a:solidFill>
-                <a:effectLst/>
-                <a:uFillTx/>
-                <a:latin typeface="Arial"/>
-              </a:rPr>
-              <a:t>e </a:t>
-            </a:r>
-            <a:r>
-              <a:rPr lang="en-US" sz="4400" b="0" u="none" strike="noStrike">
-                <a:solidFill>
-                  <a:srgbClr val="000000"/>
-                </a:solidFill>
-                <a:effectLst/>
-                <a:uFillTx/>
-                <a:latin typeface="Arial"/>
-              </a:rPr>
-              <a:t>the </a:t>
-            </a:r>
-            <a:r>
-              <a:rPr lang="en-US" sz="4400" b="0" u="none" strike="noStrike">
-                <a:solidFill>
-                  <a:srgbClr val="000000"/>
-                </a:solidFill>
-                <a:effectLst/>
-                <a:uFillTx/>
-                <a:latin typeface="Arial"/>
-              </a:rPr>
-              <a:t>slide</a:t>
+              <a:t>Click to move the slide</a:t>
             </a:r>
             <a:endParaRPr lang="en-US" sz="4400" b="0" u="none" strike="noStrike">
               <a:solidFill>
@@ -151,7 +96,7 @@
       </p:sp>
       <p:sp>
         <p:nvSpPr>
-          <p:cNvPr id="32" name="PlaceHolder 2"/>
+          <p:cNvPr id="37" name="PlaceHolder 2"/>
           <p:cNvSpPr>
             <a:spLocks noGrp="1"/>
           </p:cNvSpPr>
@@ -204,7 +149,7 @@
       </p:sp>
       <p:sp>
         <p:nvSpPr>
-          <p:cNvPr id="33" name="PlaceHolder 3"/>
+          <p:cNvPr id="38" name="PlaceHolder 3"/>
           <p:cNvSpPr>
             <a:spLocks noGrp="1"/>
           </p:cNvSpPr>
@@ -257,7 +202,7 @@
       </p:sp>
       <p:sp>
         <p:nvSpPr>
-          <p:cNvPr id="34" name="PlaceHolder 4"/>
+          <p:cNvPr id="39" name="PlaceHolder 4"/>
           <p:cNvSpPr>
             <a:spLocks noGrp="1"/>
           </p:cNvSpPr>
@@ -323,7 +268,7 @@
       </p:sp>
       <p:sp>
         <p:nvSpPr>
-          <p:cNvPr id="35" name="PlaceHolder 5"/>
+          <p:cNvPr id="40" name="PlaceHolder 5"/>
           <p:cNvSpPr>
             <a:spLocks noGrp="1"/>
           </p:cNvSpPr>
@@ -389,7 +334,7 @@
       </p:sp>
       <p:sp>
         <p:nvSpPr>
-          <p:cNvPr id="36" name="PlaceHolder 6"/>
+          <p:cNvPr id="41" name="PlaceHolder 6"/>
           <p:cNvSpPr>
             <a:spLocks noGrp="1"/>
           </p:cNvSpPr>
@@ -431,7 +376,7 @@
             <a:pPr indent="0" algn="r">
               <a:buNone/>
             </a:pPr>
-            <a:fld id="{2257D2A3-7434-4462-BEC6-3CE596D5112C}" type="slidenum">
+            <a:fld id="{7FF06812-6A4C-45AB-970B-C91701F1B3D7}" type="slidenum">
               <a:rPr lang="en-US" sz="1400" b="0" u="none" strike="noStrike">
                 <a:solidFill>
                   <a:srgbClr val="000000"/>
@@ -478,7 +423,7 @@
       </p:grpSpPr>
       <p:sp>
         <p:nvSpPr>
-          <p:cNvPr id="105" name="PlaceHolder 1"/>
+          <p:cNvPr id="110" name="PlaceHolder 1"/>
           <p:cNvSpPr>
             <a:spLocks noGrp="1"/>
           </p:cNvSpPr>
@@ -489,7 +434,7 @@
         <p:spPr>
           <a:xfrm>
             <a:off x="685800" y="1143000"/>
-            <a:ext cx="5484600" cy="3084480"/>
+            <a:ext cx="5484240" cy="3084120"/>
           </a:xfrm>
           <a:prstGeom prst="rect">
             <a:avLst/>
@@ -501,7 +446,7 @@
       </p:sp>
       <p:sp>
         <p:nvSpPr>
-          <p:cNvPr id="106" name="PlaceHolder 2"/>
+          <p:cNvPr id="111" name="PlaceHolder 2"/>
           <p:cNvSpPr>
             <a:spLocks noGrp="1"/>
           </p:cNvSpPr>
@@ -512,7 +457,7 @@
         <p:spPr>
           <a:xfrm>
             <a:off x="685800" y="4400640"/>
-            <a:ext cx="5484600" cy="3598560"/>
+            <a:ext cx="5484240" cy="3598200"/>
           </a:xfrm>
           <a:prstGeom prst="rect">
             <a:avLst/>
@@ -560,7 +505,7 @@
       </p:sp>
       <p:sp>
         <p:nvSpPr>
-          <p:cNvPr id="107" name="PlaceHolder 3"/>
+          <p:cNvPr id="112" name="PlaceHolder 3"/>
           <p:cNvSpPr>
             <a:spLocks noGrp="1"/>
           </p:cNvSpPr>
@@ -571,7 +516,7 @@
         <p:spPr>
           <a:xfrm>
             <a:off x="3884760" y="8685360"/>
-            <a:ext cx="2970000" cy="456840"/>
+            <a:ext cx="2969640" cy="456480"/>
           </a:xfrm>
           <a:prstGeom prst="rect">
             <a:avLst/>
@@ -614,7 +559,7 @@
                 <a:tab algn="l" pos="0"/>
               </a:tabLst>
             </a:pPr>
-            <a:fld id="{5F84CED3-1DF4-4D94-BFD1-598BDFEAB23F}" type="slidenum">
+            <a:fld id="{C8A32EEC-5845-4409-9A4A-A4BC1F1B5ACC}" type="slidenum">
               <a:rPr lang="en-SE" sz="1200" b="0" u="none" strike="noStrike">
                 <a:solidFill>
                   <a:srgbClr val="000000"/>
@@ -660,7 +605,7 @@
       </p:grpSpPr>
       <p:sp>
         <p:nvSpPr>
-          <p:cNvPr id="108" name="PlaceHolder 1"/>
+          <p:cNvPr id="113" name="PlaceHolder 1"/>
           <p:cNvSpPr>
             <a:spLocks noGrp="1"/>
           </p:cNvSpPr>
@@ -671,7 +616,7 @@
         <p:spPr>
           <a:xfrm>
             <a:off x="685800" y="1143000"/>
-            <a:ext cx="5484600" cy="3084480"/>
+            <a:ext cx="5484240" cy="3084120"/>
           </a:xfrm>
           <a:prstGeom prst="rect">
             <a:avLst/>
@@ -683,7 +628,7 @@
       </p:sp>
       <p:sp>
         <p:nvSpPr>
-          <p:cNvPr id="109" name="PlaceHolder 2"/>
+          <p:cNvPr id="114" name="PlaceHolder 2"/>
           <p:cNvSpPr>
             <a:spLocks noGrp="1"/>
           </p:cNvSpPr>
@@ -694,7 +639,7 @@
         <p:spPr>
           <a:xfrm>
             <a:off x="685800" y="4400640"/>
-            <a:ext cx="5484600" cy="3598560"/>
+            <a:ext cx="5484240" cy="3598200"/>
           </a:xfrm>
           <a:prstGeom prst="rect">
             <a:avLst/>
@@ -761,7 +706,7 @@
       </p:sp>
       <p:sp>
         <p:nvSpPr>
-          <p:cNvPr id="110" name="PlaceHolder 3"/>
+          <p:cNvPr id="115" name="PlaceHolder 3"/>
           <p:cNvSpPr>
             <a:spLocks noGrp="1"/>
           </p:cNvSpPr>
@@ -772,7 +717,7 @@
         <p:spPr>
           <a:xfrm>
             <a:off x="3884760" y="8685360"/>
-            <a:ext cx="2970000" cy="456840"/>
+            <a:ext cx="2969640" cy="456480"/>
           </a:xfrm>
           <a:prstGeom prst="rect">
             <a:avLst/>
@@ -815,7 +760,7 @@
                 <a:tab algn="l" pos="0"/>
               </a:tabLst>
             </a:pPr>
-            <a:fld id="{CF41B2E4-15B6-436B-ADF0-5A4826A3AB03}" type="slidenum">
+            <a:fld id="{572F1137-9773-4ACB-B9A0-6DB0799D0950}" type="slidenum">
               <a:rPr lang="en-SE" sz="1200" b="0" u="none" strike="noStrike">
                 <a:solidFill>
                   <a:srgbClr val="000000"/>
@@ -861,7 +806,7 @@
       </p:grpSpPr>
       <p:sp>
         <p:nvSpPr>
-          <p:cNvPr id="111" name="PlaceHolder 1"/>
+          <p:cNvPr id="116" name="PlaceHolder 1"/>
           <p:cNvSpPr>
             <a:spLocks noGrp="1"/>
           </p:cNvSpPr>
@@ -872,7 +817,7 @@
         <p:spPr>
           <a:xfrm>
             <a:off x="685800" y="1143000"/>
-            <a:ext cx="5484600" cy="3084480"/>
+            <a:ext cx="5484240" cy="3084120"/>
           </a:xfrm>
           <a:prstGeom prst="rect">
             <a:avLst/>
@@ -884,7 +829,7 @@
       </p:sp>
       <p:sp>
         <p:nvSpPr>
-          <p:cNvPr id="112" name="PlaceHolder 2"/>
+          <p:cNvPr id="117" name="PlaceHolder 2"/>
           <p:cNvSpPr>
             <a:spLocks noGrp="1"/>
           </p:cNvSpPr>
@@ -895,7 +840,7 @@
         <p:spPr>
           <a:xfrm>
             <a:off x="685800" y="4400640"/>
-            <a:ext cx="5484600" cy="3598560"/>
+            <a:ext cx="5484240" cy="3598200"/>
           </a:xfrm>
           <a:prstGeom prst="rect">
             <a:avLst/>
@@ -943,7 +888,7 @@
       </p:sp>
       <p:sp>
         <p:nvSpPr>
-          <p:cNvPr id="113" name="PlaceHolder 3"/>
+          <p:cNvPr id="118" name="PlaceHolder 3"/>
           <p:cNvSpPr>
             <a:spLocks noGrp="1"/>
           </p:cNvSpPr>
@@ -954,7 +899,7 @@
         <p:spPr>
           <a:xfrm>
             <a:off x="3884760" y="8685360"/>
-            <a:ext cx="2970000" cy="456840"/>
+            <a:ext cx="2969640" cy="456480"/>
           </a:xfrm>
           <a:prstGeom prst="rect">
             <a:avLst/>
@@ -997,7 +942,7 @@
                 <a:tab algn="l" pos="0"/>
               </a:tabLst>
             </a:pPr>
-            <a:fld id="{72A7D5C6-BFAC-4728-8A6C-FEB7104A5A1B}" type="slidenum">
+            <a:fld id="{F31BCC09-954E-481C-B534-217797ACA35E}" type="slidenum">
               <a:rPr lang="en-SE" sz="1200" b="0" u="none" strike="noStrike">
                 <a:solidFill>
                   <a:srgbClr val="000000"/>
@@ -1006,7 +951,7 @@
                 <a:uFillTx/>
                 <a:latin typeface="Times New Roman"/>
               </a:rPr>
-              <a:t>8</a:t>
+              <a:t>&lt;number&gt;</a:t>
             </a:fld>
             <a:endParaRPr lang="en-US" sz="1200" b="0" u="none" strike="noStrike">
               <a:solidFill>
@@ -1043,7 +988,7 @@
       </p:grpSpPr>
       <p:sp>
         <p:nvSpPr>
-          <p:cNvPr id="114" name="PlaceHolder 1"/>
+          <p:cNvPr id="119" name="PlaceHolder 1"/>
           <p:cNvSpPr>
             <a:spLocks noGrp="1"/>
           </p:cNvSpPr>
@@ -1054,7 +999,7 @@
         <p:spPr>
           <a:xfrm>
             <a:off x="685800" y="1143000"/>
-            <a:ext cx="5484600" cy="3084480"/>
+            <a:ext cx="5484240" cy="3084120"/>
           </a:xfrm>
           <a:prstGeom prst="rect">
             <a:avLst/>
@@ -1066,7 +1011,7 @@
       </p:sp>
       <p:sp>
         <p:nvSpPr>
-          <p:cNvPr id="115" name="PlaceHolder 2"/>
+          <p:cNvPr id="120" name="PlaceHolder 2"/>
           <p:cNvSpPr>
             <a:spLocks noGrp="1"/>
           </p:cNvSpPr>
@@ -1077,7 +1022,7 @@
         <p:spPr>
           <a:xfrm>
             <a:off x="685800" y="4400640"/>
-            <a:ext cx="5484600" cy="3598560"/>
+            <a:ext cx="5484240" cy="3598200"/>
           </a:xfrm>
           <a:prstGeom prst="rect">
             <a:avLst/>
@@ -1125,7 +1070,7 @@
       </p:sp>
       <p:sp>
         <p:nvSpPr>
-          <p:cNvPr id="116" name="PlaceHolder 3"/>
+          <p:cNvPr id="121" name="PlaceHolder 3"/>
           <p:cNvSpPr>
             <a:spLocks noGrp="1"/>
           </p:cNvSpPr>
@@ -1136,7 +1081,7 @@
         <p:spPr>
           <a:xfrm>
             <a:off x="3884760" y="8685360"/>
-            <a:ext cx="2970000" cy="456840"/>
+            <a:ext cx="2969640" cy="456480"/>
           </a:xfrm>
           <a:prstGeom prst="rect">
             <a:avLst/>
@@ -1179,7 +1124,7 @@
                 <a:tab algn="l" pos="0"/>
               </a:tabLst>
             </a:pPr>
-            <a:fld id="{D52AC86B-99CE-4C3F-BD3C-E322DE074583}" type="slidenum">
+            <a:fld id="{B747AC85-0403-4B97-80F9-CF8896F7224D}" type="slidenum">
               <a:rPr lang="en-SE" sz="1200" b="0" u="none" strike="noStrike">
                 <a:solidFill>
                   <a:srgbClr val="000000"/>
@@ -1225,7 +1170,7 @@
       </p:grpSpPr>
       <p:sp>
         <p:nvSpPr>
-          <p:cNvPr id="117" name="PlaceHolder 1"/>
+          <p:cNvPr id="122" name="PlaceHolder 1"/>
           <p:cNvSpPr>
             <a:spLocks noGrp="1"/>
           </p:cNvSpPr>
@@ -1236,7 +1181,7 @@
         <p:spPr>
           <a:xfrm>
             <a:off x="685800" y="1143000"/>
-            <a:ext cx="5484600" cy="3084480"/>
+            <a:ext cx="5484240" cy="3084120"/>
           </a:xfrm>
           <a:prstGeom prst="rect">
             <a:avLst/>
@@ -1248,7 +1193,7 @@
       </p:sp>
       <p:sp>
         <p:nvSpPr>
-          <p:cNvPr id="118" name="PlaceHolder 2"/>
+          <p:cNvPr id="123" name="PlaceHolder 2"/>
           <p:cNvSpPr>
             <a:spLocks noGrp="1"/>
           </p:cNvSpPr>
@@ -1259,7 +1204,7 @@
         <p:spPr>
           <a:xfrm>
             <a:off x="685800" y="4400640"/>
-            <a:ext cx="5484600" cy="3598560"/>
+            <a:ext cx="5484240" cy="3598200"/>
           </a:xfrm>
           <a:prstGeom prst="rect">
             <a:avLst/>
@@ -1307,7 +1252,7 @@
       </p:sp>
       <p:sp>
         <p:nvSpPr>
-          <p:cNvPr id="119" name="PlaceHolder 3"/>
+          <p:cNvPr id="124" name="PlaceHolder 3"/>
           <p:cNvSpPr>
             <a:spLocks noGrp="1"/>
           </p:cNvSpPr>
@@ -1318,7 +1263,7 @@
         <p:spPr>
           <a:xfrm>
             <a:off x="3884760" y="8685360"/>
-            <a:ext cx="2970000" cy="456840"/>
+            <a:ext cx="2969640" cy="456480"/>
           </a:xfrm>
           <a:prstGeom prst="rect">
             <a:avLst/>
@@ -1361,7 +1306,7 @@
                 <a:tab algn="l" pos="0"/>
               </a:tabLst>
             </a:pPr>
-            <a:fld id="{A8AD1A5E-57E5-4A2F-A55B-514EFA847A93}" type="slidenum">
+            <a:fld id="{B888A116-7EBF-449C-853F-D9F9DDA5181C}" type="slidenum">
               <a:rPr lang="en-SE" sz="1200" b="0" u="none" strike="noStrike">
                 <a:solidFill>
                   <a:srgbClr val="000000"/>
@@ -1469,7 +1414,7 @@
         <p:spPr>
           <a:xfrm>
             <a:off x="8179560" y="171360"/>
-            <a:ext cx="3603600" cy="781560"/>
+            <a:ext cx="3603240" cy="781200"/>
           </a:xfrm>
           <a:prstGeom prst="rect">
             <a:avLst/>
@@ -1489,7 +1434,7 @@
         <p:spPr>
           <a:xfrm flipH="1">
             <a:off x="0" y="6811560"/>
-            <a:ext cx="12193560" cy="1800"/>
+            <a:ext cx="12193920" cy="2160"/>
           </a:xfrm>
           <a:prstGeom prst="straightConnector1">
             <a:avLst/>
@@ -1515,7 +1460,7 @@
         <p:spPr>
           <a:xfrm>
             <a:off x="194040" y="171360"/>
-            <a:ext cx="1884240" cy="1004760"/>
+            <a:ext cx="1883880" cy="1004400"/>
           </a:xfrm>
           <a:prstGeom prst="rect">
             <a:avLst/>
@@ -1568,7 +1513,7 @@
         <p:spPr>
           <a:xfrm>
             <a:off x="8179560" y="171360"/>
-            <a:ext cx="3603600" cy="781560"/>
+            <a:ext cx="3603240" cy="781200"/>
           </a:xfrm>
           <a:prstGeom prst="rect">
             <a:avLst/>
@@ -1588,7 +1533,7 @@
         <p:spPr>
           <a:xfrm flipH="1">
             <a:off x="0" y="6811560"/>
-            <a:ext cx="12193560" cy="1800"/>
+            <a:ext cx="12193920" cy="2160"/>
           </a:xfrm>
           <a:prstGeom prst="straightConnector1">
             <a:avLst/>
@@ -1614,7 +1559,7 @@
         <p:spPr>
           <a:xfrm>
             <a:off x="194040" y="171360"/>
-            <a:ext cx="1884240" cy="1004760"/>
+            <a:ext cx="1883880" cy="1004400"/>
           </a:xfrm>
           <a:prstGeom prst="rect">
             <a:avLst/>
@@ -1638,7 +1583,7 @@
         <p:spPr>
           <a:xfrm>
             <a:off x="1523880" y="1600200"/>
-            <a:ext cx="9142200" cy="1908000"/>
+            <a:ext cx="9141840" cy="1907640"/>
           </a:xfrm>
           <a:prstGeom prst="rect">
             <a:avLst/>
@@ -1697,7 +1642,7 @@
         <p:spPr>
           <a:xfrm>
             <a:off x="609480" y="1604520"/>
-            <a:ext cx="10972080" cy="3976920"/>
+            <a:ext cx="10971720" cy="3976560"/>
           </a:xfrm>
           <a:prstGeom prst="rect">
             <a:avLst/>
@@ -1965,449 +1910,6 @@
 
 <file path=ppt/slideLayouts/slideLayout5.xml><?xml version="1.0" encoding="utf-8"?>
 <p:sldLayout xmlns:a="http://schemas.openxmlformats.org/drawingml/2006/main" xmlns:p="http://schemas.openxmlformats.org/presentationml/2006/main" xmlns:r="http://schemas.openxmlformats.org/officeDocument/2006/relationships" xmlns:p14="http://schemas.microsoft.com/office/powerpoint/2010/main" xmlns:p15="http://schemas.microsoft.com/office/powerpoint/2012/main" xmlns:mc="http://schemas.openxmlformats.org/markup-compatibility/2006" type="blank" preserve="1">
-  <p:cSld name="Default 3">
-    <p:bg>
-      <p:bgPr>
-        <a:solidFill>
-          <a:srgbClr val="ffffff"/>
-        </a:solidFill>
-      </p:bgPr>
-    </p:bg>
-    <p:spTree>
-      <p:nvGrpSpPr>
-        <p:cNvPr id="1" name=""/>
-        <p:cNvGrpSpPr/>
-        <p:nvPr/>
-      </p:nvGrpSpPr>
-      <p:grpSpPr>
-        <a:xfrm>
-          <a:off x="0" y="0"/>
-          <a:ext cx="0" cy="0"/>
-          <a:chOff x="0" y="0"/>
-          <a:chExt cx="0" cy="0"/>
-        </a:xfrm>
-      </p:grpSpPr>
-      <p:pic>
-        <p:nvPicPr>
-          <p:cNvPr id="21" name="Picture 7" descr="A close up of a logo&#10;&#10;Description automatically generated"/>
-          <p:cNvPicPr/>
-          <p:nvPr/>
-        </p:nvPicPr>
-        <p:blipFill>
-          <a:blip r:embed="rId2"/>
-          <a:stretch/>
-        </p:blipFill>
-        <p:spPr>
-          <a:xfrm>
-            <a:off x="8179560" y="171360"/>
-            <a:ext cx="3603600" cy="781560"/>
-          </a:xfrm>
-          <a:prstGeom prst="rect">
-            <a:avLst/>
-          </a:prstGeom>
-          <a:noFill/>
-          <a:ln w="0">
-            <a:noFill/>
-          </a:ln>
-        </p:spPr>
-      </p:pic>
-      <p:cxnSp>
-        <p:nvCxnSpPr>
-          <p:cNvPr id="22" name="Straight Connector 8"/>
-          <p:cNvCxnSpPr/>
-          <p:nvPr/>
-        </p:nvCxnSpPr>
-        <p:spPr>
-          <a:xfrm flipH="1">
-            <a:off x="0" y="6811560"/>
-            <a:ext cx="12193560" cy="1800"/>
-          </a:xfrm>
-          <a:prstGeom prst="straightConnector1">
-            <a:avLst/>
-          </a:prstGeom>
-          <a:ln w="101600">
-            <a:solidFill>
-              <a:srgbClr val="a7c947"/>
-            </a:solidFill>
-            <a:round/>
-          </a:ln>
-        </p:spPr>
-      </p:cxnSp>
-      <p:pic>
-        <p:nvPicPr>
-          <p:cNvPr id="23" name="Picture 9"/>
-          <p:cNvPicPr/>
-          <p:nvPr/>
-        </p:nvPicPr>
-        <p:blipFill>
-          <a:blip r:embed="rId3"/>
-          <a:stretch/>
-        </p:blipFill>
-        <p:spPr>
-          <a:xfrm>
-            <a:off x="194040" y="171360"/>
-            <a:ext cx="1884240" cy="1004760"/>
-          </a:xfrm>
-          <a:prstGeom prst="rect">
-            <a:avLst/>
-          </a:prstGeom>
-          <a:noFill/>
-          <a:ln w="0">
-            <a:noFill/>
-          </a:ln>
-        </p:spPr>
-      </p:pic>
-      <p:sp>
-        <p:nvSpPr>
-          <p:cNvPr id="24" name="PlaceHolder 1"/>
-          <p:cNvSpPr>
-            <a:spLocks noGrp="1"/>
-          </p:cNvSpPr>
-          <p:nvPr>
-            <p:ph type="title"/>
-          </p:nvPr>
-        </p:nvSpPr>
-        <p:spPr>
-          <a:xfrm>
-            <a:off x="1523880" y="1600200"/>
-            <a:ext cx="9142200" cy="1908000"/>
-          </a:xfrm>
-          <a:prstGeom prst="rect">
-            <a:avLst/>
-          </a:prstGeom>
-          <a:noFill/>
-          <a:ln w="0">
-            <a:noFill/>
-          </a:ln>
-        </p:spPr>
-        <p:txBody>
-          <a:bodyPr lIns="0" rIns="0" tIns="0" bIns="0" anchor="ctr">
-            <a:noAutofit/>
-          </a:bodyPr>
-          <a:p>
-            <a:pPr indent="0">
-              <a:lnSpc>
-                <a:spcPct val="100000"/>
-              </a:lnSpc>
-              <a:buNone/>
-              <a:tabLst>
-                <a:tab algn="l" pos="0"/>
-              </a:tabLst>
-            </a:pPr>
-            <a:r>
-              <a:rPr lang="en-US" sz="1800" b="0" u="none" strike="noStrike">
-                <a:solidFill>
-                  <a:srgbClr val="000000"/>
-                </a:solidFill>
-                <a:effectLst/>
-                <a:uFillTx/>
-                <a:latin typeface="Arial"/>
-              </a:rPr>
-              <a:t>Click to edit the title </a:t>
-            </a:r>
-            <a:r>
-              <a:rPr lang="en-US" sz="1800" b="0" u="none" strike="noStrike">
-                <a:solidFill>
-                  <a:srgbClr val="000000"/>
-                </a:solidFill>
-                <a:effectLst/>
-                <a:uFillTx/>
-                <a:latin typeface="Arial"/>
-              </a:rPr>
-              <a:t>text format</a:t>
-            </a:r>
-            <a:endParaRPr lang="en-US" sz="1800" b="0" u="none" strike="noStrike">
-              <a:solidFill>
-                <a:srgbClr val="000000"/>
-              </a:solidFill>
-              <a:effectLst/>
-              <a:uFillTx/>
-              <a:latin typeface="Arial"/>
-            </a:endParaRPr>
-          </a:p>
-        </p:txBody>
-      </p:sp>
-      <p:sp>
-        <p:nvSpPr>
-          <p:cNvPr id="25" name="PlaceHolder 2"/>
-          <p:cNvSpPr>
-            <a:spLocks noGrp="1"/>
-          </p:cNvSpPr>
-          <p:nvPr>
-            <p:ph type="body"/>
-          </p:nvPr>
-        </p:nvSpPr>
-        <p:spPr>
-          <a:xfrm>
-            <a:off x="609480" y="1604520"/>
-            <a:ext cx="10972080" cy="3976920"/>
-          </a:xfrm>
-          <a:prstGeom prst="rect">
-            <a:avLst/>
-          </a:prstGeom>
-          <a:noFill/>
-          <a:ln w="0">
-            <a:noFill/>
-          </a:ln>
-        </p:spPr>
-        <p:txBody>
-          <a:bodyPr lIns="0" rIns="0" tIns="0" bIns="0" anchor="t">
-            <a:normAutofit/>
-          </a:bodyPr>
-          <a:p>
-            <a:pPr marL="432000" indent="-324000">
-              <a:lnSpc>
-                <a:spcPct val="100000"/>
-              </a:lnSpc>
-              <a:spcBef>
-                <a:spcPts val="1417"/>
-              </a:spcBef>
-              <a:buClr>
-                <a:srgbClr val="000000"/>
-              </a:buClr>
-              <a:buSzPct val="45000"/>
-              <a:buFont typeface="Wingdings" charset="2"/>
-              <a:buChar char=""/>
-            </a:pPr>
-            <a:r>
-              <a:rPr lang="en-US" sz="3200" b="0" u="none" strike="noStrike">
-                <a:solidFill>
-                  <a:srgbClr val="000000"/>
-                </a:solidFill>
-                <a:effectLst/>
-                <a:uFillTx/>
-                <a:latin typeface="Arial"/>
-              </a:rPr>
-              <a:t>Click to edit the outline text format</a:t>
-            </a:r>
-            <a:endParaRPr lang="en-US" sz="3200" b="0" u="none" strike="noStrike">
-              <a:solidFill>
-                <a:srgbClr val="000000"/>
-              </a:solidFill>
-              <a:effectLst/>
-              <a:uFillTx/>
-              <a:latin typeface="Arial"/>
-            </a:endParaRPr>
-          </a:p>
-          <a:p>
-            <a:pPr marL="864000" lvl="1" indent="-324000">
-              <a:lnSpc>
-                <a:spcPct val="100000"/>
-              </a:lnSpc>
-              <a:spcBef>
-                <a:spcPts val="1134"/>
-              </a:spcBef>
-              <a:buClr>
-                <a:srgbClr val="000000"/>
-              </a:buClr>
-              <a:buSzPct val="75000"/>
-              <a:buFont typeface="Symbol" charset="2"/>
-              <a:buChar char=""/>
-            </a:pPr>
-            <a:r>
-              <a:rPr lang="en-US" sz="2800" b="0" u="none" strike="noStrike">
-                <a:solidFill>
-                  <a:srgbClr val="000000"/>
-                </a:solidFill>
-                <a:effectLst/>
-                <a:uFillTx/>
-                <a:latin typeface="Arial"/>
-              </a:rPr>
-              <a:t>Second Outline Level</a:t>
-            </a:r>
-            <a:endParaRPr lang="en-US" sz="2800" b="0" u="none" strike="noStrike">
-              <a:solidFill>
-                <a:srgbClr val="000000"/>
-              </a:solidFill>
-              <a:effectLst/>
-              <a:uFillTx/>
-              <a:latin typeface="Arial"/>
-            </a:endParaRPr>
-          </a:p>
-          <a:p>
-            <a:pPr marL="1296000" lvl="2" indent="-288000">
-              <a:lnSpc>
-                <a:spcPct val="100000"/>
-              </a:lnSpc>
-              <a:spcBef>
-                <a:spcPts val="850"/>
-              </a:spcBef>
-              <a:buClr>
-                <a:srgbClr val="000000"/>
-              </a:buClr>
-              <a:buSzPct val="45000"/>
-              <a:buFont typeface="Wingdings" charset="2"/>
-              <a:buChar char=""/>
-            </a:pPr>
-            <a:r>
-              <a:rPr lang="en-US" sz="2400" b="0" u="none" strike="noStrike">
-                <a:solidFill>
-                  <a:srgbClr val="000000"/>
-                </a:solidFill>
-                <a:effectLst/>
-                <a:uFillTx/>
-                <a:latin typeface="Arial"/>
-              </a:rPr>
-              <a:t>Third Outline Level</a:t>
-            </a:r>
-            <a:endParaRPr lang="en-US" sz="2400" b="0" u="none" strike="noStrike">
-              <a:solidFill>
-                <a:srgbClr val="000000"/>
-              </a:solidFill>
-              <a:effectLst/>
-              <a:uFillTx/>
-              <a:latin typeface="Arial"/>
-            </a:endParaRPr>
-          </a:p>
-          <a:p>
-            <a:pPr marL="1728000" lvl="3" indent="-216000">
-              <a:lnSpc>
-                <a:spcPct val="100000"/>
-              </a:lnSpc>
-              <a:spcBef>
-                <a:spcPts val="567"/>
-              </a:spcBef>
-              <a:buClr>
-                <a:srgbClr val="000000"/>
-              </a:buClr>
-              <a:buSzPct val="75000"/>
-              <a:buFont typeface="Symbol" charset="2"/>
-              <a:buChar char=""/>
-            </a:pPr>
-            <a:r>
-              <a:rPr lang="en-US" sz="2000" b="0" u="none" strike="noStrike">
-                <a:solidFill>
-                  <a:srgbClr val="000000"/>
-                </a:solidFill>
-                <a:effectLst/>
-                <a:uFillTx/>
-                <a:latin typeface="Arial"/>
-              </a:rPr>
-              <a:t>Fourth Outline Level</a:t>
-            </a:r>
-            <a:endParaRPr lang="en-US" sz="2000" b="0" u="none" strike="noStrike">
-              <a:solidFill>
-                <a:srgbClr val="000000"/>
-              </a:solidFill>
-              <a:effectLst/>
-              <a:uFillTx/>
-              <a:latin typeface="Arial"/>
-            </a:endParaRPr>
-          </a:p>
-          <a:p>
-            <a:pPr marL="2160000" lvl="4" indent="-216000">
-              <a:lnSpc>
-                <a:spcPct val="100000"/>
-              </a:lnSpc>
-              <a:spcBef>
-                <a:spcPts val="283"/>
-              </a:spcBef>
-              <a:buClr>
-                <a:srgbClr val="000000"/>
-              </a:buClr>
-              <a:buSzPct val="45000"/>
-              <a:buFont typeface="Wingdings" charset="2"/>
-              <a:buChar char=""/>
-            </a:pPr>
-            <a:r>
-              <a:rPr lang="en-US" sz="2000" b="0" u="none" strike="noStrike">
-                <a:solidFill>
-                  <a:srgbClr val="000000"/>
-                </a:solidFill>
-                <a:effectLst/>
-                <a:uFillTx/>
-                <a:latin typeface="Arial"/>
-              </a:rPr>
-              <a:t>Fifth Outline Level</a:t>
-            </a:r>
-            <a:endParaRPr lang="en-US" sz="2000" b="0" u="none" strike="noStrike">
-              <a:solidFill>
-                <a:srgbClr val="000000"/>
-              </a:solidFill>
-              <a:effectLst/>
-              <a:uFillTx/>
-              <a:latin typeface="Arial"/>
-            </a:endParaRPr>
-          </a:p>
-          <a:p>
-            <a:pPr marL="2592000" lvl="5" indent="-216000">
-              <a:lnSpc>
-                <a:spcPct val="100000"/>
-              </a:lnSpc>
-              <a:spcBef>
-                <a:spcPts val="283"/>
-              </a:spcBef>
-              <a:buClr>
-                <a:srgbClr val="000000"/>
-              </a:buClr>
-              <a:buSzPct val="45000"/>
-              <a:buFont typeface="Wingdings" charset="2"/>
-              <a:buChar char=""/>
-            </a:pPr>
-            <a:r>
-              <a:rPr lang="en-US" sz="2000" b="0" u="none" strike="noStrike">
-                <a:solidFill>
-                  <a:srgbClr val="000000"/>
-                </a:solidFill>
-                <a:effectLst/>
-                <a:uFillTx/>
-                <a:latin typeface="Arial"/>
-              </a:rPr>
-              <a:t>Sixth Outline Level</a:t>
-            </a:r>
-            <a:endParaRPr lang="en-US" sz="2000" b="0" u="none" strike="noStrike">
-              <a:solidFill>
-                <a:srgbClr val="000000"/>
-              </a:solidFill>
-              <a:effectLst/>
-              <a:uFillTx/>
-              <a:latin typeface="Arial"/>
-            </a:endParaRPr>
-          </a:p>
-          <a:p>
-            <a:pPr marL="3024000" lvl="6" indent="-216000">
-              <a:lnSpc>
-                <a:spcPct val="100000"/>
-              </a:lnSpc>
-              <a:spcBef>
-                <a:spcPts val="283"/>
-              </a:spcBef>
-              <a:buClr>
-                <a:srgbClr val="000000"/>
-              </a:buClr>
-              <a:buSzPct val="45000"/>
-              <a:buFont typeface="Wingdings" charset="2"/>
-              <a:buChar char=""/>
-            </a:pPr>
-            <a:r>
-              <a:rPr lang="en-US" sz="2000" b="0" u="none" strike="noStrike">
-                <a:solidFill>
-                  <a:srgbClr val="000000"/>
-                </a:solidFill>
-                <a:effectLst/>
-                <a:uFillTx/>
-                <a:latin typeface="Arial"/>
-              </a:rPr>
-              <a:t>Seventh Outline Level</a:t>
-            </a:r>
-            <a:endParaRPr lang="en-US" sz="2000" b="0" u="none" strike="noStrike">
-              <a:solidFill>
-                <a:srgbClr val="000000"/>
-              </a:solidFill>
-              <a:effectLst/>
-              <a:uFillTx/>
-              <a:latin typeface="Arial"/>
-            </a:endParaRPr>
-          </a:p>
-        </p:txBody>
-      </p:sp>
-    </p:spTree>
-  </p:cSld>
-</p:sldLayout>
-</file>
-
-<file path=ppt/slideLayouts/slideLayout6.xml><?xml version="1.0" encoding="utf-8"?>
-<p:sldLayout xmlns:a="http://schemas.openxmlformats.org/drawingml/2006/main" xmlns:p="http://schemas.openxmlformats.org/presentationml/2006/main" xmlns:r="http://schemas.openxmlformats.org/officeDocument/2006/relationships" xmlns:p14="http://schemas.microsoft.com/office/powerpoint/2010/main" xmlns:p15="http://schemas.microsoft.com/office/powerpoint/2012/main" xmlns:mc="http://schemas.openxmlformats.org/markup-compatibility/2006" type="title" preserve="1">
   <p:cSld name="Default 3">
     <p:bg>
       <p:bgPr>
@@ -2443,7 +1945,7 @@
         <p:spPr>
           <a:xfrm>
             <a:off x="8179560" y="171360"/>
-            <a:ext cx="3603600" cy="781560"/>
+            <a:ext cx="3603240" cy="781200"/>
           </a:xfrm>
           <a:prstGeom prst="rect">
             <a:avLst/>
@@ -2463,7 +1965,7 @@
         <p:spPr>
           <a:xfrm flipH="1">
             <a:off x="0" y="6811560"/>
-            <a:ext cx="12193560" cy="1800"/>
+            <a:ext cx="12193920" cy="2160"/>
           </a:xfrm>
           <a:prstGeom prst="straightConnector1">
             <a:avLst/>
@@ -2489,7 +1991,7 @@
         <p:spPr>
           <a:xfrm>
             <a:off x="194040" y="171360"/>
-            <a:ext cx="1884240" cy="1004760"/>
+            <a:ext cx="1883880" cy="1004400"/>
           </a:xfrm>
           <a:prstGeom prst="rect">
             <a:avLst/>
@@ -2513,7 +2015,7 @@
         <p:spPr>
           <a:xfrm>
             <a:off x="1523880" y="1600200"/>
-            <a:ext cx="9142200" cy="1908000"/>
+            <a:ext cx="9141840" cy="1907640"/>
           </a:xfrm>
           <a:prstGeom prst="rect">
             <a:avLst/>
@@ -2546,18 +2048,7 @@
                 <a:uFillTx/>
                 <a:latin typeface="Arial"/>
               </a:rPr>
-              <a:t>Click to edit the title </a:t>
-            </a:r>
-            <a:r>
-              <a:rPr lang="en-US" sz="1800" b="0" u="none" strike="noStrike">
-                <a:solidFill>
-                  <a:srgbClr val="000000"/>
-                </a:solidFill>
-                <a:effectLst/>
-                <a:uFillTx/>
-                <a:latin typeface="Arial"/>
-              </a:rPr>
-              <a:t>text format</a:t>
+              <a:t>Click to edit the title text format</a:t>
             </a:r>
             <a:endParaRPr lang="en-US" sz="1800" b="0" u="none" strike="noStrike">
               <a:solidFill>
@@ -2583,7 +2074,7 @@
         <p:spPr>
           <a:xfrm>
             <a:off x="609480" y="1604520"/>
-            <a:ext cx="10972080" cy="3976920"/>
+            <a:ext cx="10971720" cy="3976560"/>
           </a:xfrm>
           <a:prstGeom prst="rect">
             <a:avLst/>
@@ -2849,7 +2340,871 @@
 </p:sldLayout>
 </file>
 
+<file path=ppt/slideLayouts/slideLayout6.xml><?xml version="1.0" encoding="utf-8"?>
+<p:sldLayout xmlns:a="http://schemas.openxmlformats.org/drawingml/2006/main" xmlns:p="http://schemas.openxmlformats.org/presentationml/2006/main" xmlns:r="http://schemas.openxmlformats.org/officeDocument/2006/relationships" xmlns:p14="http://schemas.microsoft.com/office/powerpoint/2010/main" xmlns:p15="http://schemas.microsoft.com/office/powerpoint/2012/main" xmlns:mc="http://schemas.openxmlformats.org/markup-compatibility/2006" type="blank" preserve="1">
+  <p:cSld name="Default 4">
+    <p:bg>
+      <p:bgPr>
+        <a:solidFill>
+          <a:srgbClr val="ffffff"/>
+        </a:solidFill>
+      </p:bgPr>
+    </p:bg>
+    <p:spTree>
+      <p:nvGrpSpPr>
+        <p:cNvPr id="1" name=""/>
+        <p:cNvGrpSpPr/>
+        <p:nvPr/>
+      </p:nvGrpSpPr>
+      <p:grpSpPr>
+        <a:xfrm>
+          <a:off x="0" y="0"/>
+          <a:ext cx="0" cy="0"/>
+          <a:chOff x="0" y="0"/>
+          <a:chExt cx="0" cy="0"/>
+        </a:xfrm>
+      </p:grpSpPr>
+      <p:pic>
+        <p:nvPicPr>
+          <p:cNvPr id="26" name="Picture 7" descr="A close up of a logo&#10;&#10;Description automatically generated"/>
+          <p:cNvPicPr/>
+          <p:nvPr/>
+        </p:nvPicPr>
+        <p:blipFill>
+          <a:blip r:embed="rId2"/>
+          <a:stretch/>
+        </p:blipFill>
+        <p:spPr>
+          <a:xfrm>
+            <a:off x="8179560" y="171360"/>
+            <a:ext cx="3603240" cy="781200"/>
+          </a:xfrm>
+          <a:prstGeom prst="rect">
+            <a:avLst/>
+          </a:prstGeom>
+          <a:noFill/>
+          <a:ln w="0">
+            <a:noFill/>
+          </a:ln>
+        </p:spPr>
+      </p:pic>
+      <p:cxnSp>
+        <p:nvCxnSpPr>
+          <p:cNvPr id="27" name="Straight Connector 8"/>
+          <p:cNvCxnSpPr/>
+          <p:nvPr/>
+        </p:nvCxnSpPr>
+        <p:spPr>
+          <a:xfrm flipH="1">
+            <a:off x="0" y="6811560"/>
+            <a:ext cx="12193920" cy="2160"/>
+          </a:xfrm>
+          <a:prstGeom prst="straightConnector1">
+            <a:avLst/>
+          </a:prstGeom>
+          <a:ln w="101600">
+            <a:solidFill>
+              <a:srgbClr val="a7c947"/>
+            </a:solidFill>
+            <a:round/>
+          </a:ln>
+        </p:spPr>
+      </p:cxnSp>
+      <p:pic>
+        <p:nvPicPr>
+          <p:cNvPr id="28" name="Picture 9"/>
+          <p:cNvPicPr/>
+          <p:nvPr/>
+        </p:nvPicPr>
+        <p:blipFill>
+          <a:blip r:embed="rId3"/>
+          <a:stretch/>
+        </p:blipFill>
+        <p:spPr>
+          <a:xfrm>
+            <a:off x="194040" y="171360"/>
+            <a:ext cx="1883880" cy="1004400"/>
+          </a:xfrm>
+          <a:prstGeom prst="rect">
+            <a:avLst/>
+          </a:prstGeom>
+          <a:noFill/>
+          <a:ln w="0">
+            <a:noFill/>
+          </a:ln>
+        </p:spPr>
+      </p:pic>
+      <p:sp>
+        <p:nvSpPr>
+          <p:cNvPr id="29" name="PlaceHolder 1"/>
+          <p:cNvSpPr>
+            <a:spLocks noGrp="1"/>
+          </p:cNvSpPr>
+          <p:nvPr>
+            <p:ph type="title"/>
+          </p:nvPr>
+        </p:nvSpPr>
+        <p:spPr>
+          <a:xfrm>
+            <a:off x="1523880" y="1600200"/>
+            <a:ext cx="9141840" cy="1907640"/>
+          </a:xfrm>
+          <a:prstGeom prst="rect">
+            <a:avLst/>
+          </a:prstGeom>
+          <a:noFill/>
+          <a:ln w="0">
+            <a:noFill/>
+          </a:ln>
+        </p:spPr>
+        <p:txBody>
+          <a:bodyPr lIns="0" rIns="0" tIns="0" bIns="0" anchor="ctr">
+            <a:noAutofit/>
+          </a:bodyPr>
+          <a:p>
+            <a:pPr indent="0">
+              <a:lnSpc>
+                <a:spcPct val="100000"/>
+              </a:lnSpc>
+              <a:buNone/>
+              <a:tabLst>
+                <a:tab algn="l" pos="0"/>
+              </a:tabLst>
+            </a:pPr>
+            <a:r>
+              <a:rPr lang="en-US" sz="1800" b="0" u="none" strike="noStrike">
+                <a:solidFill>
+                  <a:srgbClr val="000000"/>
+                </a:solidFill>
+                <a:effectLst/>
+                <a:uFillTx/>
+                <a:latin typeface="Arial"/>
+              </a:rPr>
+              <a:t>Click to edit the title text format</a:t>
+            </a:r>
+            <a:endParaRPr lang="en-US" sz="1800" b="0" u="none" strike="noStrike">
+              <a:solidFill>
+                <a:srgbClr val="000000"/>
+              </a:solidFill>
+              <a:effectLst/>
+              <a:uFillTx/>
+              <a:latin typeface="Arial"/>
+            </a:endParaRPr>
+          </a:p>
+        </p:txBody>
+      </p:sp>
+      <p:sp>
+        <p:nvSpPr>
+          <p:cNvPr id="30" name="PlaceHolder 2"/>
+          <p:cNvSpPr>
+            <a:spLocks noGrp="1"/>
+          </p:cNvSpPr>
+          <p:nvPr>
+            <p:ph type="body"/>
+          </p:nvPr>
+        </p:nvSpPr>
+        <p:spPr>
+          <a:xfrm>
+            <a:off x="609480" y="1604520"/>
+            <a:ext cx="10971720" cy="3976560"/>
+          </a:xfrm>
+          <a:prstGeom prst="rect">
+            <a:avLst/>
+          </a:prstGeom>
+          <a:noFill/>
+          <a:ln w="0">
+            <a:noFill/>
+          </a:ln>
+        </p:spPr>
+        <p:txBody>
+          <a:bodyPr lIns="0" rIns="0" tIns="0" bIns="0" anchor="t">
+            <a:normAutofit/>
+          </a:bodyPr>
+          <a:p>
+            <a:pPr marL="432000" indent="-324000">
+              <a:lnSpc>
+                <a:spcPct val="100000"/>
+              </a:lnSpc>
+              <a:spcBef>
+                <a:spcPts val="1417"/>
+              </a:spcBef>
+              <a:buClr>
+                <a:srgbClr val="000000"/>
+              </a:buClr>
+              <a:buSzPct val="45000"/>
+              <a:buFont typeface="Wingdings" charset="2"/>
+              <a:buChar char=""/>
+            </a:pPr>
+            <a:r>
+              <a:rPr lang="en-US" sz="3200" b="0" u="none" strike="noStrike">
+                <a:solidFill>
+                  <a:srgbClr val="000000"/>
+                </a:solidFill>
+                <a:effectLst/>
+                <a:uFillTx/>
+                <a:latin typeface="Arial"/>
+              </a:rPr>
+              <a:t>Click to edit the outline text format</a:t>
+            </a:r>
+            <a:endParaRPr lang="en-US" sz="3200" b="0" u="none" strike="noStrike">
+              <a:solidFill>
+                <a:srgbClr val="000000"/>
+              </a:solidFill>
+              <a:effectLst/>
+              <a:uFillTx/>
+              <a:latin typeface="Arial"/>
+            </a:endParaRPr>
+          </a:p>
+          <a:p>
+            <a:pPr marL="864000" lvl="1" indent="-324000">
+              <a:lnSpc>
+                <a:spcPct val="100000"/>
+              </a:lnSpc>
+              <a:spcBef>
+                <a:spcPts val="1134"/>
+              </a:spcBef>
+              <a:buClr>
+                <a:srgbClr val="000000"/>
+              </a:buClr>
+              <a:buSzPct val="75000"/>
+              <a:buFont typeface="Symbol" charset="2"/>
+              <a:buChar char=""/>
+            </a:pPr>
+            <a:r>
+              <a:rPr lang="en-US" sz="2800" b="0" u="none" strike="noStrike">
+                <a:solidFill>
+                  <a:srgbClr val="000000"/>
+                </a:solidFill>
+                <a:effectLst/>
+                <a:uFillTx/>
+                <a:latin typeface="Arial"/>
+              </a:rPr>
+              <a:t>Second Outline Level</a:t>
+            </a:r>
+            <a:endParaRPr lang="en-US" sz="2800" b="0" u="none" strike="noStrike">
+              <a:solidFill>
+                <a:srgbClr val="000000"/>
+              </a:solidFill>
+              <a:effectLst/>
+              <a:uFillTx/>
+              <a:latin typeface="Arial"/>
+            </a:endParaRPr>
+          </a:p>
+          <a:p>
+            <a:pPr marL="1296000" lvl="2" indent="-288000">
+              <a:lnSpc>
+                <a:spcPct val="100000"/>
+              </a:lnSpc>
+              <a:spcBef>
+                <a:spcPts val="850"/>
+              </a:spcBef>
+              <a:buClr>
+                <a:srgbClr val="000000"/>
+              </a:buClr>
+              <a:buSzPct val="45000"/>
+              <a:buFont typeface="Wingdings" charset="2"/>
+              <a:buChar char=""/>
+            </a:pPr>
+            <a:r>
+              <a:rPr lang="en-US" sz="2400" b="0" u="none" strike="noStrike">
+                <a:solidFill>
+                  <a:srgbClr val="000000"/>
+                </a:solidFill>
+                <a:effectLst/>
+                <a:uFillTx/>
+                <a:latin typeface="Arial"/>
+              </a:rPr>
+              <a:t>Third Outline Level</a:t>
+            </a:r>
+            <a:endParaRPr lang="en-US" sz="2400" b="0" u="none" strike="noStrike">
+              <a:solidFill>
+                <a:srgbClr val="000000"/>
+              </a:solidFill>
+              <a:effectLst/>
+              <a:uFillTx/>
+              <a:latin typeface="Arial"/>
+            </a:endParaRPr>
+          </a:p>
+          <a:p>
+            <a:pPr marL="1728000" lvl="3" indent="-216000">
+              <a:lnSpc>
+                <a:spcPct val="100000"/>
+              </a:lnSpc>
+              <a:spcBef>
+                <a:spcPts val="567"/>
+              </a:spcBef>
+              <a:buClr>
+                <a:srgbClr val="000000"/>
+              </a:buClr>
+              <a:buSzPct val="75000"/>
+              <a:buFont typeface="Symbol" charset="2"/>
+              <a:buChar char=""/>
+            </a:pPr>
+            <a:r>
+              <a:rPr lang="en-US" sz="2000" b="0" u="none" strike="noStrike">
+                <a:solidFill>
+                  <a:srgbClr val="000000"/>
+                </a:solidFill>
+                <a:effectLst/>
+                <a:uFillTx/>
+                <a:latin typeface="Arial"/>
+              </a:rPr>
+              <a:t>Fourth Outline Level</a:t>
+            </a:r>
+            <a:endParaRPr lang="en-US" sz="2000" b="0" u="none" strike="noStrike">
+              <a:solidFill>
+                <a:srgbClr val="000000"/>
+              </a:solidFill>
+              <a:effectLst/>
+              <a:uFillTx/>
+              <a:latin typeface="Arial"/>
+            </a:endParaRPr>
+          </a:p>
+          <a:p>
+            <a:pPr marL="2160000" lvl="4" indent="-216000">
+              <a:lnSpc>
+                <a:spcPct val="100000"/>
+              </a:lnSpc>
+              <a:spcBef>
+                <a:spcPts val="283"/>
+              </a:spcBef>
+              <a:buClr>
+                <a:srgbClr val="000000"/>
+              </a:buClr>
+              <a:buSzPct val="45000"/>
+              <a:buFont typeface="Wingdings" charset="2"/>
+              <a:buChar char=""/>
+            </a:pPr>
+            <a:r>
+              <a:rPr lang="en-US" sz="2000" b="0" u="none" strike="noStrike">
+                <a:solidFill>
+                  <a:srgbClr val="000000"/>
+                </a:solidFill>
+                <a:effectLst/>
+                <a:uFillTx/>
+                <a:latin typeface="Arial"/>
+              </a:rPr>
+              <a:t>Fifth Outline Level</a:t>
+            </a:r>
+            <a:endParaRPr lang="en-US" sz="2000" b="0" u="none" strike="noStrike">
+              <a:solidFill>
+                <a:srgbClr val="000000"/>
+              </a:solidFill>
+              <a:effectLst/>
+              <a:uFillTx/>
+              <a:latin typeface="Arial"/>
+            </a:endParaRPr>
+          </a:p>
+          <a:p>
+            <a:pPr marL="2592000" lvl="5" indent="-216000">
+              <a:lnSpc>
+                <a:spcPct val="100000"/>
+              </a:lnSpc>
+              <a:spcBef>
+                <a:spcPts val="283"/>
+              </a:spcBef>
+              <a:buClr>
+                <a:srgbClr val="000000"/>
+              </a:buClr>
+              <a:buSzPct val="45000"/>
+              <a:buFont typeface="Wingdings" charset="2"/>
+              <a:buChar char=""/>
+            </a:pPr>
+            <a:r>
+              <a:rPr lang="en-US" sz="2000" b="0" u="none" strike="noStrike">
+                <a:solidFill>
+                  <a:srgbClr val="000000"/>
+                </a:solidFill>
+                <a:effectLst/>
+                <a:uFillTx/>
+                <a:latin typeface="Arial"/>
+              </a:rPr>
+              <a:t>Sixth Outline Level</a:t>
+            </a:r>
+            <a:endParaRPr lang="en-US" sz="2000" b="0" u="none" strike="noStrike">
+              <a:solidFill>
+                <a:srgbClr val="000000"/>
+              </a:solidFill>
+              <a:effectLst/>
+              <a:uFillTx/>
+              <a:latin typeface="Arial"/>
+            </a:endParaRPr>
+          </a:p>
+          <a:p>
+            <a:pPr marL="3024000" lvl="6" indent="-216000">
+              <a:lnSpc>
+                <a:spcPct val="100000"/>
+              </a:lnSpc>
+              <a:spcBef>
+                <a:spcPts val="283"/>
+              </a:spcBef>
+              <a:buClr>
+                <a:srgbClr val="000000"/>
+              </a:buClr>
+              <a:buSzPct val="45000"/>
+              <a:buFont typeface="Wingdings" charset="2"/>
+              <a:buChar char=""/>
+            </a:pPr>
+            <a:r>
+              <a:rPr lang="en-US" sz="2000" b="0" u="none" strike="noStrike">
+                <a:solidFill>
+                  <a:srgbClr val="000000"/>
+                </a:solidFill>
+                <a:effectLst/>
+                <a:uFillTx/>
+                <a:latin typeface="Arial"/>
+              </a:rPr>
+              <a:t>Seventh Outline Level</a:t>
+            </a:r>
+            <a:endParaRPr lang="en-US" sz="2000" b="0" u="none" strike="noStrike">
+              <a:solidFill>
+                <a:srgbClr val="000000"/>
+              </a:solidFill>
+              <a:effectLst/>
+              <a:uFillTx/>
+              <a:latin typeface="Arial"/>
+            </a:endParaRPr>
+          </a:p>
+        </p:txBody>
+      </p:sp>
+    </p:spTree>
+  </p:cSld>
+</p:sldLayout>
+</file>
+
 <file path=ppt/slideLayouts/slideLayout7.xml><?xml version="1.0" encoding="utf-8"?>
+<p:sldLayout xmlns:a="http://schemas.openxmlformats.org/drawingml/2006/main" xmlns:p="http://schemas.openxmlformats.org/presentationml/2006/main" xmlns:r="http://schemas.openxmlformats.org/officeDocument/2006/relationships" xmlns:p14="http://schemas.microsoft.com/office/powerpoint/2010/main" xmlns:p15="http://schemas.microsoft.com/office/powerpoint/2012/main" xmlns:mc="http://schemas.openxmlformats.org/markup-compatibility/2006" type="title" preserve="1">
+  <p:cSld name="Default 4">
+    <p:bg>
+      <p:bgPr>
+        <a:solidFill>
+          <a:srgbClr val="ffffff"/>
+        </a:solidFill>
+      </p:bgPr>
+    </p:bg>
+    <p:spTree>
+      <p:nvGrpSpPr>
+        <p:cNvPr id="1" name=""/>
+        <p:cNvGrpSpPr/>
+        <p:nvPr/>
+      </p:nvGrpSpPr>
+      <p:grpSpPr>
+        <a:xfrm>
+          <a:off x="0" y="0"/>
+          <a:ext cx="0" cy="0"/>
+          <a:chOff x="0" y="0"/>
+          <a:chExt cx="0" cy="0"/>
+        </a:xfrm>
+      </p:grpSpPr>
+      <p:pic>
+        <p:nvPicPr>
+          <p:cNvPr id="21" name="Picture 7" descr="A close up of a logo&#10;&#10;Description automatically generated"/>
+          <p:cNvPicPr/>
+          <p:nvPr/>
+        </p:nvPicPr>
+        <p:blipFill>
+          <a:blip r:embed="rId2"/>
+          <a:stretch/>
+        </p:blipFill>
+        <p:spPr>
+          <a:xfrm>
+            <a:off x="8179560" y="171360"/>
+            <a:ext cx="3603240" cy="781200"/>
+          </a:xfrm>
+          <a:prstGeom prst="rect">
+            <a:avLst/>
+          </a:prstGeom>
+          <a:noFill/>
+          <a:ln w="0">
+            <a:noFill/>
+          </a:ln>
+        </p:spPr>
+      </p:pic>
+      <p:cxnSp>
+        <p:nvCxnSpPr>
+          <p:cNvPr id="22" name="Straight Connector 8"/>
+          <p:cNvCxnSpPr/>
+          <p:nvPr/>
+        </p:nvCxnSpPr>
+        <p:spPr>
+          <a:xfrm flipH="1">
+            <a:off x="0" y="6811560"/>
+            <a:ext cx="12193920" cy="2160"/>
+          </a:xfrm>
+          <a:prstGeom prst="straightConnector1">
+            <a:avLst/>
+          </a:prstGeom>
+          <a:ln w="101600">
+            <a:solidFill>
+              <a:srgbClr val="a7c947"/>
+            </a:solidFill>
+            <a:round/>
+          </a:ln>
+        </p:spPr>
+      </p:cxnSp>
+      <p:pic>
+        <p:nvPicPr>
+          <p:cNvPr id="23" name="Picture 9"/>
+          <p:cNvPicPr/>
+          <p:nvPr/>
+        </p:nvPicPr>
+        <p:blipFill>
+          <a:blip r:embed="rId3"/>
+          <a:stretch/>
+        </p:blipFill>
+        <p:spPr>
+          <a:xfrm>
+            <a:off x="194040" y="171360"/>
+            <a:ext cx="1883880" cy="1004400"/>
+          </a:xfrm>
+          <a:prstGeom prst="rect">
+            <a:avLst/>
+          </a:prstGeom>
+          <a:noFill/>
+          <a:ln w="0">
+            <a:noFill/>
+          </a:ln>
+        </p:spPr>
+      </p:pic>
+      <p:sp>
+        <p:nvSpPr>
+          <p:cNvPr id="24" name="PlaceHolder 1"/>
+          <p:cNvSpPr>
+            <a:spLocks noGrp="1"/>
+          </p:cNvSpPr>
+          <p:nvPr>
+            <p:ph type="title"/>
+          </p:nvPr>
+        </p:nvSpPr>
+        <p:spPr>
+          <a:xfrm>
+            <a:off x="1523880" y="1600200"/>
+            <a:ext cx="9141840" cy="1907640"/>
+          </a:xfrm>
+          <a:prstGeom prst="rect">
+            <a:avLst/>
+          </a:prstGeom>
+          <a:noFill/>
+          <a:ln w="0">
+            <a:noFill/>
+          </a:ln>
+        </p:spPr>
+        <p:txBody>
+          <a:bodyPr lIns="0" rIns="0" tIns="0" bIns="0" anchor="ctr">
+            <a:noAutofit/>
+          </a:bodyPr>
+          <a:p>
+            <a:pPr indent="0">
+              <a:lnSpc>
+                <a:spcPct val="100000"/>
+              </a:lnSpc>
+              <a:buNone/>
+              <a:tabLst>
+                <a:tab algn="l" pos="0"/>
+              </a:tabLst>
+            </a:pPr>
+            <a:r>
+              <a:rPr lang="en-US" sz="1800" b="0" u="none" strike="noStrike">
+                <a:solidFill>
+                  <a:srgbClr val="000000"/>
+                </a:solidFill>
+                <a:effectLst/>
+                <a:uFillTx/>
+                <a:latin typeface="Arial"/>
+              </a:rPr>
+              <a:t>Click to edit the title text format</a:t>
+            </a:r>
+            <a:endParaRPr lang="en-US" sz="1800" b="0" u="none" strike="noStrike">
+              <a:solidFill>
+                <a:srgbClr val="000000"/>
+              </a:solidFill>
+              <a:effectLst/>
+              <a:uFillTx/>
+              <a:latin typeface="Arial"/>
+            </a:endParaRPr>
+          </a:p>
+        </p:txBody>
+      </p:sp>
+      <p:sp>
+        <p:nvSpPr>
+          <p:cNvPr id="25" name="PlaceHolder 2"/>
+          <p:cNvSpPr>
+            <a:spLocks noGrp="1"/>
+          </p:cNvSpPr>
+          <p:nvPr>
+            <p:ph type="body"/>
+          </p:nvPr>
+        </p:nvSpPr>
+        <p:spPr>
+          <a:xfrm>
+            <a:off x="609480" y="1604520"/>
+            <a:ext cx="10971720" cy="3976560"/>
+          </a:xfrm>
+          <a:prstGeom prst="rect">
+            <a:avLst/>
+          </a:prstGeom>
+          <a:noFill/>
+          <a:ln w="0">
+            <a:noFill/>
+          </a:ln>
+        </p:spPr>
+        <p:txBody>
+          <a:bodyPr lIns="0" rIns="0" tIns="0" bIns="0" anchor="t">
+            <a:normAutofit/>
+          </a:bodyPr>
+          <a:p>
+            <a:pPr marL="432000" indent="-324000">
+              <a:lnSpc>
+                <a:spcPct val="100000"/>
+              </a:lnSpc>
+              <a:spcBef>
+                <a:spcPts val="1417"/>
+              </a:spcBef>
+              <a:buClr>
+                <a:srgbClr val="000000"/>
+              </a:buClr>
+              <a:buSzPct val="45000"/>
+              <a:buFont typeface="Wingdings" charset="2"/>
+              <a:buChar char=""/>
+            </a:pPr>
+            <a:r>
+              <a:rPr lang="en-US" sz="3200" b="0" u="none" strike="noStrike">
+                <a:solidFill>
+                  <a:srgbClr val="000000"/>
+                </a:solidFill>
+                <a:effectLst/>
+                <a:uFillTx/>
+                <a:latin typeface="Arial"/>
+              </a:rPr>
+              <a:t>Click to edit the outline text format</a:t>
+            </a:r>
+            <a:endParaRPr lang="en-US" sz="3200" b="0" u="none" strike="noStrike">
+              <a:solidFill>
+                <a:srgbClr val="000000"/>
+              </a:solidFill>
+              <a:effectLst/>
+              <a:uFillTx/>
+              <a:latin typeface="Arial"/>
+            </a:endParaRPr>
+          </a:p>
+          <a:p>
+            <a:pPr marL="864000" lvl="1" indent="-324000">
+              <a:lnSpc>
+                <a:spcPct val="100000"/>
+              </a:lnSpc>
+              <a:spcBef>
+                <a:spcPts val="1134"/>
+              </a:spcBef>
+              <a:buClr>
+                <a:srgbClr val="000000"/>
+              </a:buClr>
+              <a:buSzPct val="75000"/>
+              <a:buFont typeface="Symbol" charset="2"/>
+              <a:buChar char=""/>
+            </a:pPr>
+            <a:r>
+              <a:rPr lang="en-US" sz="2800" b="0" u="none" strike="noStrike">
+                <a:solidFill>
+                  <a:srgbClr val="000000"/>
+                </a:solidFill>
+                <a:effectLst/>
+                <a:uFillTx/>
+                <a:latin typeface="Arial"/>
+              </a:rPr>
+              <a:t>Second Outline Level</a:t>
+            </a:r>
+            <a:endParaRPr lang="en-US" sz="2800" b="0" u="none" strike="noStrike">
+              <a:solidFill>
+                <a:srgbClr val="000000"/>
+              </a:solidFill>
+              <a:effectLst/>
+              <a:uFillTx/>
+              <a:latin typeface="Arial"/>
+            </a:endParaRPr>
+          </a:p>
+          <a:p>
+            <a:pPr marL="1296000" lvl="2" indent="-288000">
+              <a:lnSpc>
+                <a:spcPct val="100000"/>
+              </a:lnSpc>
+              <a:spcBef>
+                <a:spcPts val="850"/>
+              </a:spcBef>
+              <a:buClr>
+                <a:srgbClr val="000000"/>
+              </a:buClr>
+              <a:buSzPct val="45000"/>
+              <a:buFont typeface="Wingdings" charset="2"/>
+              <a:buChar char=""/>
+            </a:pPr>
+            <a:r>
+              <a:rPr lang="en-US" sz="2400" b="0" u="none" strike="noStrike">
+                <a:solidFill>
+                  <a:srgbClr val="000000"/>
+                </a:solidFill>
+                <a:effectLst/>
+                <a:uFillTx/>
+                <a:latin typeface="Arial"/>
+              </a:rPr>
+              <a:t>Third Outline Level</a:t>
+            </a:r>
+            <a:endParaRPr lang="en-US" sz="2400" b="0" u="none" strike="noStrike">
+              <a:solidFill>
+                <a:srgbClr val="000000"/>
+              </a:solidFill>
+              <a:effectLst/>
+              <a:uFillTx/>
+              <a:latin typeface="Arial"/>
+            </a:endParaRPr>
+          </a:p>
+          <a:p>
+            <a:pPr marL="1728000" lvl="3" indent="-216000">
+              <a:lnSpc>
+                <a:spcPct val="100000"/>
+              </a:lnSpc>
+              <a:spcBef>
+                <a:spcPts val="567"/>
+              </a:spcBef>
+              <a:buClr>
+                <a:srgbClr val="000000"/>
+              </a:buClr>
+              <a:buSzPct val="75000"/>
+              <a:buFont typeface="Symbol" charset="2"/>
+              <a:buChar char=""/>
+            </a:pPr>
+            <a:r>
+              <a:rPr lang="en-US" sz="2000" b="0" u="none" strike="noStrike">
+                <a:solidFill>
+                  <a:srgbClr val="000000"/>
+                </a:solidFill>
+                <a:effectLst/>
+                <a:uFillTx/>
+                <a:latin typeface="Arial"/>
+              </a:rPr>
+              <a:t>Fourth Outline Level</a:t>
+            </a:r>
+            <a:endParaRPr lang="en-US" sz="2000" b="0" u="none" strike="noStrike">
+              <a:solidFill>
+                <a:srgbClr val="000000"/>
+              </a:solidFill>
+              <a:effectLst/>
+              <a:uFillTx/>
+              <a:latin typeface="Arial"/>
+            </a:endParaRPr>
+          </a:p>
+          <a:p>
+            <a:pPr marL="2160000" lvl="4" indent="-216000">
+              <a:lnSpc>
+                <a:spcPct val="100000"/>
+              </a:lnSpc>
+              <a:spcBef>
+                <a:spcPts val="283"/>
+              </a:spcBef>
+              <a:buClr>
+                <a:srgbClr val="000000"/>
+              </a:buClr>
+              <a:buSzPct val="45000"/>
+              <a:buFont typeface="Wingdings" charset="2"/>
+              <a:buChar char=""/>
+            </a:pPr>
+            <a:r>
+              <a:rPr lang="en-US" sz="2000" b="0" u="none" strike="noStrike">
+                <a:solidFill>
+                  <a:srgbClr val="000000"/>
+                </a:solidFill>
+                <a:effectLst/>
+                <a:uFillTx/>
+                <a:latin typeface="Arial"/>
+              </a:rPr>
+              <a:t>Fifth Outline Level</a:t>
+            </a:r>
+            <a:endParaRPr lang="en-US" sz="2000" b="0" u="none" strike="noStrike">
+              <a:solidFill>
+                <a:srgbClr val="000000"/>
+              </a:solidFill>
+              <a:effectLst/>
+              <a:uFillTx/>
+              <a:latin typeface="Arial"/>
+            </a:endParaRPr>
+          </a:p>
+          <a:p>
+            <a:pPr marL="2592000" lvl="5" indent="-216000">
+              <a:lnSpc>
+                <a:spcPct val="100000"/>
+              </a:lnSpc>
+              <a:spcBef>
+                <a:spcPts val="283"/>
+              </a:spcBef>
+              <a:buClr>
+                <a:srgbClr val="000000"/>
+              </a:buClr>
+              <a:buSzPct val="45000"/>
+              <a:buFont typeface="Wingdings" charset="2"/>
+              <a:buChar char=""/>
+            </a:pPr>
+            <a:r>
+              <a:rPr lang="en-US" sz="2000" b="0" u="none" strike="noStrike">
+                <a:solidFill>
+                  <a:srgbClr val="000000"/>
+                </a:solidFill>
+                <a:effectLst/>
+                <a:uFillTx/>
+                <a:latin typeface="Arial"/>
+              </a:rPr>
+              <a:t>Sixth Outline Level</a:t>
+            </a:r>
+            <a:endParaRPr lang="en-US" sz="2000" b="0" u="none" strike="noStrike">
+              <a:solidFill>
+                <a:srgbClr val="000000"/>
+              </a:solidFill>
+              <a:effectLst/>
+              <a:uFillTx/>
+              <a:latin typeface="Arial"/>
+            </a:endParaRPr>
+          </a:p>
+          <a:p>
+            <a:pPr marL="3024000" lvl="6" indent="-216000">
+              <a:lnSpc>
+                <a:spcPct val="100000"/>
+              </a:lnSpc>
+              <a:spcBef>
+                <a:spcPts val="283"/>
+              </a:spcBef>
+              <a:buClr>
+                <a:srgbClr val="000000"/>
+              </a:buClr>
+              <a:buSzPct val="45000"/>
+              <a:buFont typeface="Wingdings" charset="2"/>
+              <a:buChar char=""/>
+            </a:pPr>
+            <a:r>
+              <a:rPr lang="en-US" sz="2000" b="0" u="none" strike="noStrike">
+                <a:solidFill>
+                  <a:srgbClr val="000000"/>
+                </a:solidFill>
+                <a:effectLst/>
+                <a:uFillTx/>
+                <a:latin typeface="Arial"/>
+              </a:rPr>
+              <a:t>Seventh Outline Level</a:t>
+            </a:r>
+            <a:endParaRPr lang="en-US" sz="2000" b="0" u="none" strike="noStrike">
+              <a:solidFill>
+                <a:srgbClr val="000000"/>
+              </a:solidFill>
+              <a:effectLst/>
+              <a:uFillTx/>
+              <a:latin typeface="Arial"/>
+            </a:endParaRPr>
+          </a:p>
+        </p:txBody>
+      </p:sp>
+    </p:spTree>
+  </p:cSld>
+</p:sldLayout>
+</file>
+
+<file path=ppt/slideLayouts/slideLayout8.xml><?xml version="1.0" encoding="utf-8"?>
 <p:sldLayout xmlns:a="http://schemas.openxmlformats.org/drawingml/2006/main" xmlns:p="http://schemas.openxmlformats.org/presentationml/2006/main" xmlns:r="http://schemas.openxmlformats.org/officeDocument/2006/relationships" xmlns:p14="http://schemas.microsoft.com/office/powerpoint/2010/main" xmlns:p15="http://schemas.microsoft.com/office/powerpoint/2012/main" xmlns:mc="http://schemas.openxmlformats.org/markup-compatibility/2006" type="blank" preserve="1">
   <p:cSld name="One column_no bulletpoints">
     <p:spTree>
@@ -2908,7 +3263,7 @@
         <p:spPr>
           <a:xfrm>
             <a:off x="8179560" y="171360"/>
-            <a:ext cx="3603600" cy="781560"/>
+            <a:ext cx="3603240" cy="781200"/>
           </a:xfrm>
           <a:prstGeom prst="rect">
             <a:avLst/>
@@ -2928,7 +3283,7 @@
         <p:spPr>
           <a:xfrm flipH="1">
             <a:off x="0" y="6811560"/>
-            <a:ext cx="12193560" cy="1800"/>
+            <a:ext cx="12193920" cy="2160"/>
           </a:xfrm>
           <a:prstGeom prst="straightConnector1">
             <a:avLst/>
@@ -2954,7 +3309,7 @@
         <p:spPr>
           <a:xfrm>
             <a:off x="194040" y="171360"/>
-            <a:ext cx="1884240" cy="1004760"/>
+            <a:ext cx="1883880" cy="1004400"/>
           </a:xfrm>
           <a:prstGeom prst="rect">
             <a:avLst/>
@@ -3011,7 +3366,7 @@
         <p:spPr>
           <a:xfrm>
             <a:off x="8179560" y="171360"/>
-            <a:ext cx="3603600" cy="781560"/>
+            <a:ext cx="3603240" cy="781200"/>
           </a:xfrm>
           <a:prstGeom prst="rect">
             <a:avLst/>
@@ -3031,7 +3386,7 @@
         <p:spPr>
           <a:xfrm flipH="1">
             <a:off x="0" y="6811560"/>
-            <a:ext cx="12193560" cy="1800"/>
+            <a:ext cx="12193920" cy="2160"/>
           </a:xfrm>
           <a:prstGeom prst="straightConnector1">
             <a:avLst/>
@@ -3057,7 +3412,7 @@
         <p:spPr>
           <a:xfrm>
             <a:off x="194040" y="171360"/>
-            <a:ext cx="1884240" cy="1004760"/>
+            <a:ext cx="1883880" cy="1004400"/>
           </a:xfrm>
           <a:prstGeom prst="rect">
             <a:avLst/>
@@ -3102,11 +3457,12 @@
     <p:sldLayoutId id="2147483654" r:id="rId3"/>
     <p:sldLayoutId id="2147483655" r:id="rId4"/>
     <p:sldLayoutId id="2147483656" r:id="rId5"/>
+    <p:sldLayoutId id="2147483657" r:id="rId6"/>
   </p:sldLayoutIdLst>
 </p:sldMaster>
 </file>
 
-<file path=ppt/slideMasters/slideMaster6.xml><?xml version="1.0" encoding="utf-8"?>
+<file path=ppt/slideMasters/slideMaster7.xml><?xml version="1.0" encoding="utf-8"?>
 <p:sldMaster xmlns:a="http://schemas.openxmlformats.org/drawingml/2006/main" xmlns:p="http://schemas.openxmlformats.org/presentationml/2006/main" xmlns:r="http://schemas.openxmlformats.org/officeDocument/2006/relationships" xmlns:p14="http://schemas.microsoft.com/office/powerpoint/2010/main" xmlns:p15="http://schemas.microsoft.com/office/powerpoint/2012/main" xmlns:mc="http://schemas.openxmlformats.org/markup-compatibility/2006">
   <p:cSld>
     <p:bg>
@@ -3132,7 +3488,7 @@
       </p:grpSpPr>
       <p:pic>
         <p:nvPicPr>
-          <p:cNvPr id="26" name="Picture 24" descr="A picture containing light&#10;&#10;Description automatically generated"/>
+          <p:cNvPr id="31" name="Picture 24" descr="A picture containing light&#10;&#10;Description automatically generated"/>
           <p:cNvPicPr/>
           <p:nvPr/>
         </p:nvPicPr>
@@ -3143,7 +3499,7 @@
         <p:spPr>
           <a:xfrm>
             <a:off x="11541600" y="6271560"/>
-            <a:ext cx="503640" cy="476280"/>
+            <a:ext cx="503280" cy="475920"/>
           </a:xfrm>
           <a:prstGeom prst="rect">
             <a:avLst/>
@@ -3156,14 +3512,14 @@
       </p:pic>
       <p:cxnSp>
         <p:nvCxnSpPr>
-          <p:cNvPr id="27" name="Straight Connector 25"/>
+          <p:cNvPr id="32" name="Straight Connector 25"/>
           <p:cNvCxnSpPr/>
           <p:nvPr/>
         </p:nvCxnSpPr>
         <p:spPr>
           <a:xfrm>
             <a:off x="430920" y="881640"/>
-            <a:ext cx="11331360" cy="1800"/>
+            <a:ext cx="11331720" cy="2160"/>
           </a:xfrm>
           <a:prstGeom prst="straightConnector1">
             <a:avLst/>
@@ -3178,7 +3534,7 @@
       </p:cxnSp>
       <p:pic>
         <p:nvPicPr>
-          <p:cNvPr id="28" name="Picture 8"/>
+          <p:cNvPr id="33" name="Picture 8"/>
           <p:cNvPicPr/>
           <p:nvPr/>
         </p:nvPicPr>
@@ -3189,7 +3545,7 @@
         <p:spPr>
           <a:xfrm>
             <a:off x="144720" y="6271560"/>
-            <a:ext cx="1294560" cy="476280"/>
+            <a:ext cx="1294200" cy="475920"/>
           </a:xfrm>
           <a:prstGeom prst="rect">
             <a:avLst/>
@@ -3202,7 +3558,7 @@
       </p:pic>
       <p:sp>
         <p:nvSpPr>
-          <p:cNvPr id="29" name="PlaceHolder 1"/>
+          <p:cNvPr id="34" name="PlaceHolder 1"/>
           <p:cNvSpPr>
             <a:spLocks noGrp="1"/>
           </p:cNvSpPr>
@@ -3240,7 +3596,40 @@
                 <a:uFillTx/>
                 <a:latin typeface="Arial"/>
               </a:rPr>
-              <a:t>Click to edit the title text format</a:t>
+              <a:t>Click to </a:t>
+            </a:r>
+            <a:r>
+              <a:rPr lang="en-US" sz="4400" b="0" u="none" strike="noStrike">
+                <a:solidFill>
+                  <a:srgbClr val="000000"/>
+                </a:solidFill>
+                <a:effectLst/>
+                <a:uFillTx/>
+                <a:latin typeface="Arial"/>
+              </a:rPr>
+              <a:t>edit the </a:t>
+            </a:r>
+            <a:r>
+              <a:rPr lang="en-US" sz="4400" b="0" u="none" strike="noStrike">
+                <a:solidFill>
+                  <a:srgbClr val="000000"/>
+                </a:solidFill>
+                <a:effectLst/>
+                <a:uFillTx/>
+                <a:latin typeface="Arial"/>
+              </a:rPr>
+              <a:t>title text </a:t>
+            </a:r>
+            <a:r>
+              <a:rPr lang="en-US" sz="4400" b="0" u="none" strike="noStrike">
+                <a:solidFill>
+                  <a:srgbClr val="000000"/>
+                </a:solidFill>
+                <a:effectLst/>
+                <a:uFillTx/>
+                <a:latin typeface="Arial"/>
+              </a:rPr>
+              <a:t>format</a:t>
             </a:r>
             <a:endParaRPr lang="en-US" sz="4400" b="0" u="none" strike="noStrike">
               <a:solidFill>
@@ -3255,7 +3644,7 @@
       </p:sp>
       <p:sp>
         <p:nvSpPr>
-          <p:cNvPr id="30" name="PlaceHolder 2"/>
+          <p:cNvPr id="35" name="PlaceHolder 2"/>
           <p:cNvSpPr>
             <a:spLocks noGrp="1"/>
           </p:cNvSpPr>
@@ -3510,7 +3899,7 @@
   </p:cSld>
   <p:clrMap bg1="lt1" tx1="dk1" bg2="lt2" tx2="dk2" accent1="accent1" accent2="accent2" accent3="accent3" accent4="accent4" accent5="accent5" accent6="accent6" hlink="hlink" folHlink="folHlink"/>
   <p:sldLayoutIdLst>
-    <p:sldLayoutId id="2147483658" r:id="rId4"/>
+    <p:sldLayoutId id="2147483659" r:id="rId4"/>
   </p:sldLayoutIdLst>
 </p:sldMaster>
 </file>
@@ -3534,7 +3923,7 @@
       </p:grpSpPr>
       <p:sp>
         <p:nvSpPr>
-          <p:cNvPr id="37" name="PlaceHolder 1"/>
+          <p:cNvPr id="42" name="PlaceHolder 1"/>
           <p:cNvSpPr>
             <a:spLocks noGrp="1"/>
           </p:cNvSpPr>
@@ -3545,7 +3934,7 @@
         <p:spPr>
           <a:xfrm>
             <a:off x="1523880" y="1600200"/>
-            <a:ext cx="9142200" cy="1908000"/>
+            <a:ext cx="9141840" cy="1907640"/>
           </a:xfrm>
           <a:prstGeom prst="rect">
             <a:avLst/>
@@ -3580,7 +3969,85 @@
                 <a:uFillTx/>
                 <a:latin typeface="Arial"/>
               </a:rPr>
-              <a:t>Introduction to Bioinformatics using NGS data</a:t>
+              <a:t>Introdu</a:t>
+            </a:r>
+            <a:r>
+              <a:rPr lang="sv-SE" sz="4000" b="1" u="none" strike="noStrike">
+                <a:solidFill>
+                  <a:schemeClr val="lt2">
+                    <a:lumMod val="10000"/>
+                  </a:schemeClr>
+                </a:solidFill>
+                <a:effectLst/>
+                <a:uFillTx/>
+                <a:latin typeface="Arial"/>
+              </a:rPr>
+              <a:t>ction to </a:t>
+            </a:r>
+            <a:r>
+              <a:rPr lang="sv-SE" sz="4000" b="1" u="none" strike="noStrike">
+                <a:solidFill>
+                  <a:schemeClr val="lt2">
+                    <a:lumMod val="10000"/>
+                  </a:schemeClr>
+                </a:solidFill>
+                <a:effectLst/>
+                <a:uFillTx/>
+                <a:latin typeface="Arial"/>
+              </a:rPr>
+              <a:t>Bioinfo</a:t>
+            </a:r>
+            <a:r>
+              <a:rPr lang="sv-SE" sz="4000" b="1" u="none" strike="noStrike">
+                <a:solidFill>
+                  <a:schemeClr val="lt2">
+                    <a:lumMod val="10000"/>
+                  </a:schemeClr>
+                </a:solidFill>
+                <a:effectLst/>
+                <a:uFillTx/>
+                <a:latin typeface="Arial"/>
+              </a:rPr>
+              <a:t>rmatics </a:t>
+            </a:r>
+            <a:r>
+              <a:rPr lang="sv-SE" sz="4000" b="1" u="none" strike="noStrike">
+                <a:solidFill>
+                  <a:schemeClr val="lt2">
+                    <a:lumMod val="10000"/>
+                  </a:schemeClr>
+                </a:solidFill>
+                <a:effectLst/>
+                <a:uFillTx/>
+                <a:latin typeface="Arial"/>
+              </a:rPr>
+              <a:t>using </a:t>
+            </a:r>
+            <a:r>
+              <a:rPr lang="sv-SE" sz="4000" b="1" u="none" strike="noStrike">
+                <a:solidFill>
+                  <a:schemeClr val="lt2">
+                    <a:lumMod val="10000"/>
+                  </a:schemeClr>
+                </a:solidFill>
+                <a:effectLst/>
+                <a:uFillTx/>
+                <a:latin typeface="Arial"/>
+              </a:rPr>
+              <a:t>NGS </a:t>
+            </a:r>
+            <a:r>
+              <a:rPr lang="sv-SE" sz="4000" b="1" u="none" strike="noStrike">
+                <a:solidFill>
+                  <a:schemeClr val="lt2">
+                    <a:lumMod val="10000"/>
+                  </a:schemeClr>
+                </a:solidFill>
+                <a:effectLst/>
+                <a:uFillTx/>
+                <a:latin typeface="Arial"/>
+              </a:rPr>
+              <a:t>data</a:t>
             </a:r>
             <a:endParaRPr lang="en-US" sz="4000" b="0" u="none" strike="noStrike">
               <a:solidFill>
@@ -3595,7 +4062,7 @@
       </p:sp>
       <p:sp>
         <p:nvSpPr>
-          <p:cNvPr id="38" name="PlaceHolder 2"/>
+          <p:cNvPr id="43" name="PlaceHolder 2"/>
           <p:cNvSpPr>
             <a:spLocks noGrp="1"/>
           </p:cNvSpPr>
@@ -3606,7 +4073,7 @@
         <p:spPr>
           <a:xfrm>
             <a:off x="1523880" y="3602160"/>
-            <a:ext cx="9142200" cy="1653840"/>
+            <a:ext cx="9141840" cy="1653480"/>
           </a:xfrm>
           <a:prstGeom prst="rect">
             <a:avLst/>
@@ -3667,7 +4134,7 @@
       </p:grpSpPr>
       <p:sp>
         <p:nvSpPr>
-          <p:cNvPr id="39" name="PlaceHolder 1"/>
+          <p:cNvPr id="44" name="PlaceHolder 1"/>
           <p:cNvSpPr>
             <a:spLocks noGrp="1"/>
           </p:cNvSpPr>
@@ -3678,7 +4145,7 @@
         <p:spPr>
           <a:xfrm>
             <a:off x="431280" y="321480"/>
-            <a:ext cx="11327760" cy="543960"/>
+            <a:ext cx="11327400" cy="543600"/>
           </a:xfrm>
           <a:prstGeom prst="rect">
             <a:avLst/>
@@ -3728,21 +4195,21 @@
       </p:sp>
       <p:grpSp>
         <p:nvGrpSpPr>
-          <p:cNvPr id="40" name="Group 13"/>
+          <p:cNvPr id="45" name="Group 13"/>
           <p:cNvGrpSpPr/>
           <p:nvPr/>
         </p:nvGrpSpPr>
         <p:grpSpPr>
           <a:xfrm>
             <a:off x="1176120" y="1154520"/>
-            <a:ext cx="3187800" cy="4709520"/>
+            <a:ext cx="3187440" cy="4709160"/>
             <a:chOff x="1176120" y="1154520"/>
-            <a:chExt cx="3187800" cy="4709520"/>
+            <a:chExt cx="3187440" cy="4709160"/>
           </a:xfrm>
         </p:grpSpPr>
         <p:pic>
           <p:nvPicPr>
-            <p:cNvPr id="41" name="Picture 4"/>
+            <p:cNvPr id="46" name="Picture 4"/>
             <p:cNvPicPr/>
             <p:nvPr/>
           </p:nvPicPr>
@@ -3753,7 +4220,7 @@
           <p:spPr>
             <a:xfrm>
               <a:off x="1176120" y="1523880"/>
-              <a:ext cx="3187800" cy="4340160"/>
+              <a:ext cx="3187440" cy="4339800"/>
             </a:xfrm>
             <a:prstGeom prst="rect">
               <a:avLst/>
@@ -3766,7 +4233,7 @@
         </p:pic>
         <p:sp>
           <p:nvSpPr>
-            <p:cNvPr id="42" name="TextBox 11"/>
+            <p:cNvPr id="47" name="TextBox 11"/>
             <p:cNvSpPr/>
             <p:nvPr/>
           </p:nvSpPr>
@@ -3824,14 +4291,14 @@
       </p:grpSp>
       <p:sp>
         <p:nvSpPr>
-          <p:cNvPr id="43" name="Rectangle 10"/>
+          <p:cNvPr id="48" name="Rectangle 10"/>
           <p:cNvSpPr/>
           <p:nvPr/>
         </p:nvSpPr>
         <p:spPr>
           <a:xfrm>
             <a:off x="1218600" y="5397480"/>
-            <a:ext cx="3092760" cy="384120"/>
+            <a:ext cx="3092400" cy="383760"/>
           </a:xfrm>
           <a:prstGeom prst="rect">
             <a:avLst/>
@@ -3881,7 +4348,7 @@
       </p:sp>
       <p:sp>
         <p:nvSpPr>
-          <p:cNvPr id="44" name="PlaceHolder 2"/>
+          <p:cNvPr id="49" name="PlaceHolder 2"/>
           <p:cNvSpPr>
             <a:spLocks noGrp="1"/>
           </p:cNvSpPr>
@@ -3892,7 +4359,7 @@
         <p:spPr>
           <a:xfrm>
             <a:off x="6729120" y="4221720"/>
-            <a:ext cx="1745280" cy="1642320"/>
+            <a:ext cx="1744920" cy="1641960"/>
           </a:xfrm>
           <a:prstGeom prst="rect">
             <a:avLst/>
@@ -3965,14 +4432,14 @@
       </p:sp>
       <p:sp>
         <p:nvSpPr>
-          <p:cNvPr id="45" name="Rectangle 10"/>
+          <p:cNvPr id="50" name="Rectangle 10"/>
           <p:cNvSpPr/>
           <p:nvPr/>
         </p:nvSpPr>
         <p:spPr>
           <a:xfrm>
             <a:off x="1218600" y="1561320"/>
-            <a:ext cx="3092760" cy="384120"/>
+            <a:ext cx="3092400" cy="383760"/>
           </a:xfrm>
           <a:prstGeom prst="rect">
             <a:avLst/>
@@ -4022,14 +4489,14 @@
       </p:sp>
       <p:sp>
         <p:nvSpPr>
-          <p:cNvPr id="46" name="Rektangel 6"/>
+          <p:cNvPr id="51" name="Rektangel 6"/>
           <p:cNvSpPr/>
           <p:nvPr/>
         </p:nvSpPr>
         <p:spPr>
           <a:xfrm>
             <a:off x="11408040" y="6074280"/>
-            <a:ext cx="749520" cy="760320"/>
+            <a:ext cx="749160" cy="759960"/>
           </a:xfrm>
           <a:prstGeom prst="rect">
             <a:avLst/>
@@ -4080,7 +4547,7 @@
       </p:sp>
       <p:pic>
         <p:nvPicPr>
-          <p:cNvPr id="47" name="Bild 3"/>
+          <p:cNvPr id="52" name="Bild 3"/>
           <p:cNvPicPr/>
           <p:nvPr/>
         </p:nvPicPr>
@@ -4097,7 +4564,7 @@
         <p:spPr>
           <a:xfrm>
             <a:off x="10055160" y="6172200"/>
-            <a:ext cx="2027160" cy="645480"/>
+            <a:ext cx="2026800" cy="645120"/>
           </a:xfrm>
           <a:prstGeom prst="rect">
             <a:avLst/>
@@ -4110,7 +4577,7 @@
       </p:pic>
       <p:pic>
         <p:nvPicPr>
-          <p:cNvPr id="48" name="Google Shape;32;p2"/>
+          <p:cNvPr id="53" name="Google Shape;32;p2"/>
           <p:cNvPicPr/>
           <p:nvPr/>
         </p:nvPicPr>
@@ -4121,7 +4588,7 @@
         <p:spPr>
           <a:xfrm>
             <a:off x="4673160" y="1531080"/>
-            <a:ext cx="4309920" cy="2571480"/>
+            <a:ext cx="4309560" cy="2571120"/>
           </a:xfrm>
           <a:prstGeom prst="rect">
             <a:avLst/>
@@ -4134,7 +4601,7 @@
       </p:pic>
       <p:pic>
         <p:nvPicPr>
-          <p:cNvPr id="49" name="Google Shape;33;p2" descr="A group of people standing outside a building&#10;&#10;Description automatically generated with medium confidence"/>
+          <p:cNvPr id="54" name="Google Shape;33;p2" descr="A group of people standing outside a building&#10;&#10;Description automatically generated with medium confidence"/>
           <p:cNvPicPr/>
           <p:nvPr/>
         </p:nvPicPr>
@@ -4145,7 +4612,7 @@
         <p:spPr>
           <a:xfrm>
             <a:off x="457560" y="-2971800"/>
-            <a:ext cx="6171480" cy="2630520"/>
+            <a:ext cx="6171120" cy="2630160"/>
           </a:xfrm>
           <a:prstGeom prst="rect">
             <a:avLst/>
@@ -4158,14 +4625,14 @@
       </p:pic>
       <p:sp>
         <p:nvSpPr>
-          <p:cNvPr id="50" name="Google Shape;34;p2"/>
+          <p:cNvPr id="55" name="Google Shape;34;p2"/>
           <p:cNvSpPr/>
           <p:nvPr/>
         </p:nvSpPr>
         <p:spPr>
           <a:xfrm>
             <a:off x="6533280" y="3769560"/>
-            <a:ext cx="2179080" cy="2128680"/>
+            <a:ext cx="2178720" cy="2128320"/>
           </a:xfrm>
           <a:prstGeom prst="ellipse">
             <a:avLst/>
@@ -4207,35 +4674,35 @@
       </p:sp>
       <p:grpSp>
         <p:nvGrpSpPr>
-          <p:cNvPr id="51" name="Google Shape;36;p2"/>
+          <p:cNvPr id="56" name="Google Shape;36;p2"/>
           <p:cNvGrpSpPr/>
           <p:nvPr/>
         </p:nvGrpSpPr>
         <p:grpSpPr>
           <a:xfrm>
             <a:off x="9218880" y="2005560"/>
-            <a:ext cx="2239920" cy="3858480"/>
+            <a:ext cx="2239560" cy="3858120"/>
             <a:chOff x="9218880" y="2005560"/>
-            <a:chExt cx="2239920" cy="3858480"/>
+            <a:chExt cx="2239560" cy="3858120"/>
           </a:xfrm>
         </p:grpSpPr>
         <p:grpSp>
           <p:nvGrpSpPr>
-            <p:cNvPr id="52" name="Google Shape;37;p2"/>
+            <p:cNvPr id="57" name="Google Shape;37;p2"/>
             <p:cNvGrpSpPr/>
             <p:nvPr/>
           </p:nvGrpSpPr>
           <p:grpSpPr>
             <a:xfrm>
               <a:off x="9569520" y="2005560"/>
-              <a:ext cx="1889280" cy="3858480"/>
+              <a:ext cx="1888920" cy="3858120"/>
               <a:chOff x="9569520" y="2005560"/>
-              <a:chExt cx="1889280" cy="3858480"/>
+              <a:chExt cx="1888920" cy="3858120"/>
             </a:xfrm>
           </p:grpSpPr>
           <p:pic>
             <p:nvPicPr>
-              <p:cNvPr id="53" name="Google Shape;38;p2"/>
+              <p:cNvPr id="58" name="Google Shape;38;p2"/>
               <p:cNvPicPr/>
               <p:nvPr/>
             </p:nvPicPr>
@@ -4243,13 +4710,13 @@
               <a:blip r:embed="rId6">
                 <a:alphaModFix amt="70000"/>
               </a:blip>
-              <a:srcRect l="33331" t="0" r="32917" b="0"/>
+              <a:srcRect l="33326" t="0" r="32914" b="0"/>
               <a:stretch/>
             </p:blipFill>
             <p:spPr>
               <a:xfrm>
                 <a:off x="9569520" y="2005560"/>
-                <a:ext cx="1889280" cy="3858480"/>
+                <a:ext cx="1888920" cy="3858120"/>
               </a:xfrm>
               <a:prstGeom prst="rect">
                 <a:avLst/>
@@ -4262,14 +4729,14 @@
           </p:pic>
           <p:sp>
             <p:nvSpPr>
-              <p:cNvPr id="54" name="Google Shape;39;p2"/>
+              <p:cNvPr id="59" name="Google Shape;39;p2"/>
               <p:cNvSpPr/>
               <p:nvPr/>
             </p:nvSpPr>
             <p:spPr>
               <a:xfrm>
                 <a:off x="9912600" y="5574600"/>
-                <a:ext cx="58320" cy="53280"/>
+                <a:ext cx="57960" cy="52920"/>
               </a:xfrm>
               <a:prstGeom prst="ellipse">
                 <a:avLst/>
@@ -4291,7 +4758,7 @@
               <a:fontRef idx="minor"/>
             </p:style>
             <p:txBody>
-              <a:bodyPr lIns="90000" rIns="90000" tIns="19080" bIns="19080" anchor="ctr">
+              <a:bodyPr lIns="90000" rIns="90000" tIns="18720" bIns="18720" anchor="ctr">
                 <a:noAutofit/>
               </a:bodyPr>
               <a:p>
@@ -4314,14 +4781,14 @@
           </p:sp>
           <p:sp>
             <p:nvSpPr>
-              <p:cNvPr id="55" name="Google Shape;40;p2"/>
+              <p:cNvPr id="60" name="Google Shape;40;p2"/>
               <p:cNvSpPr/>
               <p:nvPr/>
             </p:nvSpPr>
             <p:spPr>
               <a:xfrm>
                 <a:off x="9763200" y="5167440"/>
-                <a:ext cx="58320" cy="53280"/>
+                <a:ext cx="57960" cy="52920"/>
               </a:xfrm>
               <a:prstGeom prst="ellipse">
                 <a:avLst/>
@@ -4343,7 +4810,7 @@
               <a:fontRef idx="minor"/>
             </p:style>
             <p:txBody>
-              <a:bodyPr lIns="90000" rIns="90000" tIns="19080" bIns="19080" anchor="ctr">
+              <a:bodyPr lIns="90000" rIns="90000" tIns="18720" bIns="18720" anchor="ctr">
                 <a:noAutofit/>
               </a:bodyPr>
               <a:p>
@@ -4366,14 +4833,14 @@
           </p:sp>
           <p:sp>
             <p:nvSpPr>
-              <p:cNvPr id="56" name="Google Shape;41;p2"/>
+              <p:cNvPr id="61" name="Google Shape;41;p2"/>
               <p:cNvSpPr/>
               <p:nvPr/>
             </p:nvSpPr>
             <p:spPr>
               <a:xfrm>
                 <a:off x="10467720" y="4689720"/>
-                <a:ext cx="58320" cy="53280"/>
+                <a:ext cx="57960" cy="52920"/>
               </a:xfrm>
               <a:prstGeom prst="ellipse">
                 <a:avLst/>
@@ -4395,7 +4862,7 @@
               <a:fontRef idx="minor"/>
             </p:style>
             <p:txBody>
-              <a:bodyPr lIns="90000" rIns="90000" tIns="19080" bIns="19080" anchor="ctr">
+              <a:bodyPr lIns="90000" rIns="90000" tIns="18720" bIns="18720" anchor="ctr">
                 <a:noAutofit/>
               </a:bodyPr>
               <a:p>
@@ -4418,14 +4885,14 @@
           </p:sp>
           <p:sp>
             <p:nvSpPr>
-              <p:cNvPr id="57" name="Google Shape;42;p2"/>
+              <p:cNvPr id="62" name="Google Shape;42;p2"/>
               <p:cNvSpPr/>
               <p:nvPr/>
             </p:nvSpPr>
             <p:spPr>
               <a:xfrm>
                 <a:off x="10519200" y="4775400"/>
-                <a:ext cx="58320" cy="53280"/>
+                <a:ext cx="57960" cy="52920"/>
               </a:xfrm>
               <a:prstGeom prst="ellipse">
                 <a:avLst/>
@@ -4447,7 +4914,7 @@
               <a:fontRef idx="minor"/>
             </p:style>
             <p:txBody>
-              <a:bodyPr lIns="90000" rIns="90000" tIns="19080" bIns="19080" anchor="ctr">
+              <a:bodyPr lIns="90000" rIns="90000" tIns="18720" bIns="18720" anchor="ctr">
                 <a:noAutofit/>
               </a:bodyPr>
               <a:p>
@@ -4470,14 +4937,14 @@
           </p:sp>
           <p:sp>
             <p:nvSpPr>
-              <p:cNvPr id="58" name="Google Shape;43;p2"/>
+              <p:cNvPr id="63" name="Google Shape;43;p2"/>
               <p:cNvSpPr/>
               <p:nvPr/>
             </p:nvSpPr>
             <p:spPr>
               <a:xfrm>
                 <a:off x="10227960" y="4974840"/>
-                <a:ext cx="58320" cy="53280"/>
+                <a:ext cx="57960" cy="52920"/>
               </a:xfrm>
               <a:prstGeom prst="ellipse">
                 <a:avLst/>
@@ -4499,7 +4966,7 @@
               <a:fontRef idx="minor"/>
             </p:style>
             <p:txBody>
-              <a:bodyPr lIns="90000" rIns="90000" tIns="19080" bIns="19080" anchor="ctr">
+              <a:bodyPr lIns="90000" rIns="90000" tIns="18720" bIns="18720" anchor="ctr">
                 <a:noAutofit/>
               </a:bodyPr>
               <a:p>
@@ -4522,14 +4989,14 @@
           </p:sp>
           <p:sp>
             <p:nvSpPr>
-              <p:cNvPr id="59" name="Google Shape;44;p2"/>
+              <p:cNvPr id="64" name="Google Shape;44;p2"/>
               <p:cNvSpPr/>
               <p:nvPr/>
             </p:nvSpPr>
             <p:spPr>
               <a:xfrm>
                 <a:off x="10816920" y="3651480"/>
-                <a:ext cx="58320" cy="53280"/>
+                <a:ext cx="57960" cy="52920"/>
               </a:xfrm>
               <a:prstGeom prst="ellipse">
                 <a:avLst/>
@@ -4551,7 +5018,7 @@
               <a:fontRef idx="minor"/>
             </p:style>
             <p:txBody>
-              <a:bodyPr lIns="90000" rIns="90000" tIns="19080" bIns="19080" anchor="ctr">
+              <a:bodyPr lIns="90000" rIns="90000" tIns="18720" bIns="18720" anchor="ctr">
                 <a:noAutofit/>
               </a:bodyPr>
               <a:p>
@@ -4575,14 +5042,14 @@
         </p:grpSp>
         <p:sp>
           <p:nvSpPr>
-            <p:cNvPr id="60" name="Google Shape;45;p2"/>
+            <p:cNvPr id="65" name="Google Shape;45;p2"/>
             <p:cNvSpPr/>
             <p:nvPr/>
           </p:nvSpPr>
           <p:spPr>
             <a:xfrm>
               <a:off x="10793160" y="3549600"/>
-              <a:ext cx="507240" cy="191520"/>
+              <a:ext cx="506880" cy="191520"/>
             </a:xfrm>
             <a:prstGeom prst="rect">
               <a:avLst/>
@@ -4633,14 +5100,14 @@
         </p:sp>
         <p:sp>
           <p:nvSpPr>
-            <p:cNvPr id="61" name="Google Shape;46;p2"/>
+            <p:cNvPr id="66" name="Google Shape;46;p2"/>
             <p:cNvSpPr/>
             <p:nvPr/>
           </p:nvSpPr>
           <p:spPr>
             <a:xfrm>
               <a:off x="10478520" y="4739760"/>
-              <a:ext cx="675360" cy="191520"/>
+              <a:ext cx="675000" cy="191520"/>
             </a:xfrm>
             <a:prstGeom prst="rect">
               <a:avLst/>
@@ -4691,14 +5158,14 @@
         </p:sp>
         <p:sp>
           <p:nvSpPr>
-            <p:cNvPr id="62" name="Google Shape;47;p2"/>
+            <p:cNvPr id="67" name="Google Shape;47;p2"/>
             <p:cNvSpPr/>
             <p:nvPr/>
           </p:nvSpPr>
           <p:spPr>
             <a:xfrm>
               <a:off x="10542600" y="4472280"/>
-              <a:ext cx="509760" cy="191520"/>
+              <a:ext cx="509400" cy="191520"/>
             </a:xfrm>
             <a:prstGeom prst="rect">
               <a:avLst/>
@@ -4749,14 +5216,14 @@
         </p:sp>
         <p:sp>
           <p:nvSpPr>
-            <p:cNvPr id="63" name="Google Shape;48;p2"/>
+            <p:cNvPr id="68" name="Google Shape;48;p2"/>
             <p:cNvSpPr/>
             <p:nvPr/>
           </p:nvSpPr>
           <p:spPr>
             <a:xfrm>
               <a:off x="10334880" y="4908960"/>
-              <a:ext cx="564480" cy="191520"/>
+              <a:ext cx="564120" cy="191520"/>
             </a:xfrm>
             <a:prstGeom prst="rect">
               <a:avLst/>
@@ -4807,14 +5274,14 @@
         </p:sp>
         <p:sp>
           <p:nvSpPr>
-            <p:cNvPr id="64" name="Google Shape;49;p2"/>
+            <p:cNvPr id="69" name="Google Shape;49;p2"/>
             <p:cNvSpPr/>
             <p:nvPr/>
           </p:nvSpPr>
           <p:spPr>
             <a:xfrm>
               <a:off x="9218880" y="5015880"/>
-              <a:ext cx="558000" cy="191520"/>
+              <a:ext cx="557640" cy="191520"/>
             </a:xfrm>
             <a:prstGeom prst="rect">
               <a:avLst/>
@@ -4865,14 +5332,14 @@
         </p:sp>
         <p:sp>
           <p:nvSpPr>
-            <p:cNvPr id="65" name="Google Shape;50;p2"/>
+            <p:cNvPr id="70" name="Google Shape;50;p2"/>
             <p:cNvSpPr/>
             <p:nvPr/>
           </p:nvSpPr>
           <p:spPr>
             <a:xfrm>
               <a:off x="9572040" y="5571000"/>
-              <a:ext cx="381600" cy="191520"/>
+              <a:ext cx="381240" cy="191520"/>
             </a:xfrm>
             <a:prstGeom prst="rect">
               <a:avLst/>
@@ -4924,14 +5391,14 @@
       </p:grpSp>
       <p:sp>
         <p:nvSpPr>
-          <p:cNvPr id="66" name="Google Shape;51;p2"/>
+          <p:cNvPr id="71" name="Google Shape;51;p2"/>
           <p:cNvSpPr/>
           <p:nvPr/>
         </p:nvSpPr>
         <p:spPr>
           <a:xfrm>
             <a:off x="6729120" y="4221720"/>
-            <a:ext cx="1745280" cy="1642320"/>
+            <a:ext cx="1744920" cy="1641960"/>
           </a:xfrm>
           <a:prstGeom prst="rect">
             <a:avLst/>
@@ -5005,14 +5472,14 @@
       </p:sp>
       <p:cxnSp>
         <p:nvCxnSpPr>
-          <p:cNvPr id="67" name="Google Shape;52;p2"/>
+          <p:cNvPr id="72" name="Google Shape;52;p2"/>
           <p:cNvCxnSpPr/>
           <p:nvPr/>
         </p:nvCxnSpPr>
         <p:spPr>
           <a:xfrm flipV="1">
             <a:off x="8400240" y="3723840"/>
-            <a:ext cx="2310480" cy="681480"/>
+            <a:ext cx="2310840" cy="681840"/>
           </a:xfrm>
           <a:prstGeom prst="straightConnector1">
             <a:avLst/>
@@ -5028,14 +5495,14 @@
       </p:cxnSp>
       <p:cxnSp>
         <p:nvCxnSpPr>
-          <p:cNvPr id="68" name="Google Shape;53;p2"/>
+          <p:cNvPr id="73" name="Google Shape;53;p2"/>
           <p:cNvCxnSpPr/>
           <p:nvPr/>
         </p:nvCxnSpPr>
         <p:spPr>
           <a:xfrm>
             <a:off x="8397720" y="5234400"/>
-            <a:ext cx="1486800" cy="369720"/>
+            <a:ext cx="1487160" cy="370080"/>
           </a:xfrm>
           <a:prstGeom prst="straightConnector1">
             <a:avLst/>
@@ -5051,14 +5518,14 @@
       </p:cxnSp>
       <p:cxnSp>
         <p:nvCxnSpPr>
-          <p:cNvPr id="69" name="Google Shape;54;p2"/>
+          <p:cNvPr id="74" name="Google Shape;54;p2"/>
           <p:cNvCxnSpPr/>
           <p:nvPr/>
         </p:nvCxnSpPr>
         <p:spPr>
           <a:xfrm>
             <a:off x="8544240" y="4709880"/>
-            <a:ext cx="1839240" cy="24120"/>
+            <a:ext cx="1839600" cy="24480"/>
           </a:xfrm>
           <a:prstGeom prst="straightConnector1">
             <a:avLst/>
@@ -5074,14 +5541,14 @@
       </p:cxnSp>
       <p:cxnSp>
         <p:nvCxnSpPr>
-          <p:cNvPr id="70" name="Google Shape;55;p2"/>
+          <p:cNvPr id="75" name="Google Shape;55;p2"/>
           <p:cNvCxnSpPr/>
           <p:nvPr/>
         </p:nvCxnSpPr>
         <p:spPr>
           <a:xfrm>
             <a:off x="8466120" y="5129280"/>
-            <a:ext cx="1204200" cy="67320"/>
+            <a:ext cx="1204560" cy="67680"/>
           </a:xfrm>
           <a:prstGeom prst="straightConnector1">
             <a:avLst/>
@@ -5097,14 +5564,14 @@
       </p:cxnSp>
       <p:cxnSp>
         <p:nvCxnSpPr>
-          <p:cNvPr id="71" name="Google Shape;56;p2"/>
+          <p:cNvPr id="76" name="Google Shape;56;p2"/>
           <p:cNvCxnSpPr/>
           <p:nvPr/>
         </p:nvCxnSpPr>
         <p:spPr>
           <a:xfrm>
             <a:off x="8510760" y="4818600"/>
-            <a:ext cx="1839240" cy="24120"/>
+            <a:ext cx="1839600" cy="24480"/>
           </a:xfrm>
           <a:prstGeom prst="straightConnector1">
             <a:avLst/>
@@ -5120,14 +5587,14 @@
       </p:cxnSp>
       <p:cxnSp>
         <p:nvCxnSpPr>
-          <p:cNvPr id="72" name="Google Shape;57;p2"/>
+          <p:cNvPr id="77" name="Google Shape;57;p2"/>
           <p:cNvCxnSpPr/>
           <p:nvPr/>
         </p:nvCxnSpPr>
         <p:spPr>
           <a:xfrm>
             <a:off x="8499240" y="4941360"/>
-            <a:ext cx="1608840" cy="59400"/>
+            <a:ext cx="1609200" cy="59760"/>
           </a:xfrm>
           <a:prstGeom prst="straightConnector1">
             <a:avLst/>
@@ -5185,7 +5652,7 @@
                                           </p:stCondLst>
                                         </p:cTn>
                                         <p:tgtEl>
-                                          <p:spTgt spid="43"/>
+                                          <p:spTgt spid="48"/>
                                         </p:tgtEl>
                                         <p:attrNameLst>
                                           <p:attrName>style.visibility</p:attrName>
@@ -5212,7 +5679,7 @@
                                           </p:stCondLst>
                                         </p:cTn>
                                         <p:tgtEl>
-                                          <p:spTgt spid="44">
+                                          <p:spTgt spid="49">
                                             <p:txEl>
                                               <p:pRg st="0" end="0"/>
                                             </p:txEl>
@@ -5261,7 +5728,7 @@
                                           </p:stCondLst>
                                         </p:cTn>
                                         <p:tgtEl>
-                                          <p:spTgt spid="45"/>
+                                          <p:spTgt spid="50"/>
                                         </p:tgtEl>
                                         <p:attrNameLst>
                                           <p:attrName>style.visibility</p:attrName>
@@ -5324,7 +5791,7 @@
       </p:grpSpPr>
       <p:sp>
         <p:nvSpPr>
-          <p:cNvPr id="73" name="PlaceHolder 1"/>
+          <p:cNvPr id="78" name="PlaceHolder 1"/>
           <p:cNvSpPr>
             <a:spLocks noGrp="1"/>
           </p:cNvSpPr>
@@ -5335,7 +5802,7 @@
         <p:spPr>
           <a:xfrm>
             <a:off x="431280" y="321480"/>
-            <a:ext cx="11327760" cy="543960"/>
+            <a:ext cx="11327400" cy="543600"/>
           </a:xfrm>
           <a:prstGeom prst="rect">
             <a:avLst/>
@@ -5385,28 +5852,28 @@
       </p:sp>
       <p:grpSp>
         <p:nvGrpSpPr>
-          <p:cNvPr id="74" name="Group 19"/>
+          <p:cNvPr id="79" name="Group 19"/>
           <p:cNvGrpSpPr/>
           <p:nvPr/>
         </p:nvGrpSpPr>
         <p:grpSpPr>
           <a:xfrm>
             <a:off x="1752480" y="3010320"/>
-            <a:ext cx="8694720" cy="1042560"/>
+            <a:ext cx="8694360" cy="1042200"/>
             <a:chOff x="1752480" y="3010320"/>
-            <a:chExt cx="8694720" cy="1042560"/>
+            <a:chExt cx="8694360" cy="1042200"/>
           </a:xfrm>
         </p:grpSpPr>
         <p:sp>
           <p:nvSpPr>
-            <p:cNvPr id="75" name="Right Arrow 3"/>
+            <p:cNvPr id="80" name="Right Arrow 3"/>
             <p:cNvSpPr/>
             <p:nvPr/>
           </p:nvSpPr>
           <p:spPr>
             <a:xfrm>
               <a:off x="8305200" y="3010320"/>
-              <a:ext cx="2142000" cy="1042560"/>
+              <a:ext cx="2141640" cy="1042200"/>
             </a:xfrm>
             <a:prstGeom prst="rightArrow">
               <a:avLst>
@@ -5469,14 +5936,14 @@
         </p:sp>
         <p:sp>
           <p:nvSpPr>
-            <p:cNvPr id="76" name="Rectangle 4"/>
+            <p:cNvPr id="81" name="Rectangle 4"/>
             <p:cNvSpPr/>
             <p:nvPr/>
           </p:nvSpPr>
           <p:spPr>
             <a:xfrm>
               <a:off x="2734920" y="3268440"/>
-              <a:ext cx="1320120" cy="522720"/>
+              <a:ext cx="1319760" cy="522360"/>
             </a:xfrm>
             <a:prstGeom prst="rect">
               <a:avLst/>
@@ -5552,14 +6019,14 @@
         </p:sp>
         <p:sp>
           <p:nvSpPr>
-            <p:cNvPr id="77" name="Rectangle 5"/>
+            <p:cNvPr id="82" name="Rectangle 5"/>
             <p:cNvSpPr/>
             <p:nvPr/>
           </p:nvSpPr>
           <p:spPr>
             <a:xfrm>
               <a:off x="4056840" y="3268440"/>
-              <a:ext cx="1222200" cy="522720"/>
+              <a:ext cx="1221840" cy="522360"/>
             </a:xfrm>
             <a:prstGeom prst="rect">
               <a:avLst/>
@@ -5621,14 +6088,14 @@
         </p:sp>
         <p:sp>
           <p:nvSpPr>
-            <p:cNvPr id="78" name="Rectangle 6"/>
+            <p:cNvPr id="83" name="Rectangle 6"/>
             <p:cNvSpPr/>
             <p:nvPr/>
           </p:nvSpPr>
           <p:spPr>
             <a:xfrm>
               <a:off x="5280840" y="3268440"/>
-              <a:ext cx="3022560" cy="522720"/>
+              <a:ext cx="3022200" cy="522360"/>
             </a:xfrm>
             <a:prstGeom prst="rect">
               <a:avLst/>
@@ -5690,14 +6157,14 @@
         </p:sp>
         <p:sp>
           <p:nvSpPr>
-            <p:cNvPr id="79" name="Rectangle 11"/>
+            <p:cNvPr id="84" name="Rectangle 11"/>
             <p:cNvSpPr/>
             <p:nvPr/>
           </p:nvSpPr>
           <p:spPr>
             <a:xfrm>
               <a:off x="1752480" y="3268440"/>
-              <a:ext cx="980640" cy="522720"/>
+              <a:ext cx="980280" cy="522360"/>
             </a:xfrm>
             <a:prstGeom prst="rect">
               <a:avLst/>
@@ -5760,28 +6227,28 @@
       </p:grpSp>
       <p:grpSp>
         <p:nvGrpSpPr>
-          <p:cNvPr id="80" name="Group 23"/>
+          <p:cNvPr id="85" name="Group 23"/>
           <p:cNvGrpSpPr/>
           <p:nvPr/>
         </p:nvGrpSpPr>
         <p:grpSpPr>
           <a:xfrm>
             <a:off x="5280840" y="2251440"/>
-            <a:ext cx="4638240" cy="651600"/>
+            <a:ext cx="4637880" cy="651600"/>
             <a:chOff x="5280840" y="2251440"/>
-            <a:chExt cx="4638240" cy="651600"/>
+            <a:chExt cx="4637880" cy="651600"/>
           </a:xfrm>
         </p:grpSpPr>
         <p:sp>
           <p:nvSpPr>
-            <p:cNvPr id="81" name="Right Brace 8"/>
+            <p:cNvPr id="86" name="Right Brace 8"/>
             <p:cNvSpPr/>
             <p:nvPr/>
           </p:nvSpPr>
           <p:spPr>
             <a:xfrm rot="16200000">
-              <a:off x="7450200" y="434160"/>
-              <a:ext cx="299520" cy="4638240"/>
+              <a:off x="7450200" y="434520"/>
+              <a:ext cx="299160" cy="4637880"/>
             </a:xfrm>
             <a:prstGeom prst="rightBrace">
               <a:avLst>
@@ -5831,7 +6298,7 @@
         </p:sp>
         <p:pic>
           <p:nvPicPr>
-            <p:cNvPr id="82" name="Picture 16"/>
+            <p:cNvPr id="87" name="Picture 16"/>
             <p:cNvPicPr/>
             <p:nvPr/>
           </p:nvPicPr>
@@ -5842,7 +6309,7 @@
           <p:spPr>
             <a:xfrm>
               <a:off x="7192800" y="2251440"/>
-              <a:ext cx="814680" cy="299520"/>
+              <a:ext cx="814320" cy="299160"/>
             </a:xfrm>
             <a:prstGeom prst="rect">
               <a:avLst/>
@@ -5856,28 +6323,28 @@
       </p:grpSp>
       <p:grpSp>
         <p:nvGrpSpPr>
-          <p:cNvPr id="83" name="Group 22"/>
+          <p:cNvPr id="88" name="Group 22"/>
           <p:cNvGrpSpPr/>
           <p:nvPr/>
         </p:nvGrpSpPr>
         <p:grpSpPr>
           <a:xfrm>
             <a:off x="1775160" y="2251440"/>
-            <a:ext cx="936000" cy="688320"/>
+            <a:ext cx="935640" cy="688320"/>
             <a:chOff x="1775160" y="2251440"/>
-            <a:chExt cx="936000" cy="688320"/>
+            <a:chExt cx="935640" cy="688320"/>
           </a:xfrm>
         </p:grpSpPr>
         <p:sp>
           <p:nvSpPr>
-            <p:cNvPr id="84" name="Right Brace 17"/>
+            <p:cNvPr id="89" name="Right Brace 17"/>
             <p:cNvSpPr/>
             <p:nvPr/>
           </p:nvSpPr>
           <p:spPr>
             <a:xfrm rot="16200000">
-              <a:off x="2077920" y="2306520"/>
-              <a:ext cx="330480" cy="936000"/>
+              <a:off x="2077920" y="2306880"/>
+              <a:ext cx="330120" cy="935640"/>
             </a:xfrm>
             <a:prstGeom prst="rightBrace">
               <a:avLst>
@@ -5927,7 +6394,7 @@
         </p:sp>
         <p:pic>
           <p:nvPicPr>
-            <p:cNvPr id="85" name="Picture 18"/>
+            <p:cNvPr id="90" name="Picture 18"/>
             <p:cNvPicPr/>
             <p:nvPr/>
           </p:nvPicPr>
@@ -5938,7 +6405,7 @@
           <p:spPr>
             <a:xfrm>
               <a:off x="1829880" y="2251440"/>
-              <a:ext cx="814680" cy="299520"/>
+              <a:ext cx="814320" cy="299160"/>
             </a:xfrm>
             <a:prstGeom prst="rect">
               <a:avLst/>
@@ -5952,14 +6419,14 @@
       </p:grpSp>
       <p:sp>
         <p:nvSpPr>
-          <p:cNvPr id="86" name="Right Brace 7"/>
+          <p:cNvPr id="91" name="Right Brace 7"/>
           <p:cNvSpPr/>
           <p:nvPr/>
         </p:nvSpPr>
         <p:spPr>
           <a:xfrm rot="5400000">
-            <a:off x="3347280" y="2530800"/>
-            <a:ext cx="330480" cy="3536280"/>
+            <a:off x="3347640" y="2530800"/>
+            <a:ext cx="330120" cy="3535920"/>
           </a:xfrm>
           <a:prstGeom prst="rightBrace">
             <a:avLst>
@@ -6009,7 +6476,7 @@
       </p:sp>
       <p:pic>
         <p:nvPicPr>
-          <p:cNvPr id="87" name="Bild 10"/>
+          <p:cNvPr id="92" name="Bild 10"/>
           <p:cNvPicPr/>
           <p:nvPr/>
         </p:nvPicPr>
@@ -6026,7 +6493,7 @@
         <p:spPr>
           <a:xfrm>
             <a:off x="2197440" y="4534560"/>
-            <a:ext cx="2626920" cy="836640"/>
+            <a:ext cx="2626560" cy="836280"/>
           </a:xfrm>
           <a:prstGeom prst="rect">
             <a:avLst/>
@@ -6081,7 +6548,7 @@
                                           </p:stCondLst>
                                         </p:cTn>
                                         <p:tgtEl>
-                                          <p:spTgt spid="83"/>
+                                          <p:spTgt spid="88"/>
                                         </p:tgtEl>
                                         <p:attrNameLst>
                                           <p:attrName>style.visibility</p:attrName>
@@ -6126,7 +6593,7 @@
                                           </p:stCondLst>
                                         </p:cTn>
                                         <p:tgtEl>
-                                          <p:spTgt spid="80"/>
+                                          <p:spTgt spid="85"/>
                                         </p:tgtEl>
                                         <p:attrNameLst>
                                           <p:attrName>style.visibility</p:attrName>
@@ -6189,7 +6656,7 @@
       </p:grpSpPr>
       <p:sp>
         <p:nvSpPr>
-          <p:cNvPr id="88" name="PlaceHolder 1"/>
+          <p:cNvPr id="93" name="PlaceHolder 1"/>
           <p:cNvSpPr>
             <a:spLocks noGrp="1"/>
           </p:cNvSpPr>
@@ -6200,7 +6667,7 @@
         <p:spPr>
           <a:xfrm>
             <a:off x="431280" y="321480"/>
-            <a:ext cx="11327760" cy="543960"/>
+            <a:ext cx="11327400" cy="543600"/>
           </a:xfrm>
           <a:prstGeom prst="rect">
             <a:avLst/>
@@ -6250,7 +6717,7 @@
       </p:sp>
       <p:sp>
         <p:nvSpPr>
-          <p:cNvPr id="89" name="textruta 5"/>
+          <p:cNvPr id="94" name="textruta 5"/>
           <p:cNvSpPr/>
           <p:nvPr/>
         </p:nvSpPr>
@@ -6307,7 +6774,7 @@
       </p:sp>
       <p:sp>
         <p:nvSpPr>
-          <p:cNvPr id="90" name="textruta 6"/>
+          <p:cNvPr id="95" name="textruta 6"/>
           <p:cNvSpPr/>
           <p:nvPr/>
         </p:nvSpPr>
@@ -6375,7 +6842,7 @@
       </p:sp>
       <p:sp>
         <p:nvSpPr>
-          <p:cNvPr id="91" name="textruta 7"/>
+          <p:cNvPr id="96" name="textruta 7"/>
           <p:cNvSpPr/>
           <p:nvPr/>
         </p:nvSpPr>
@@ -6432,7 +6899,7 @@
       </p:sp>
       <p:pic>
         <p:nvPicPr>
-          <p:cNvPr id="92" name="Content Placeholder 9"/>
+          <p:cNvPr id="97" name="Content Placeholder 9"/>
           <p:cNvPicPr/>
           <p:nvPr/>
         </p:nvPicPr>
@@ -6443,7 +6910,7 @@
         <p:spPr>
           <a:xfrm>
             <a:off x="1422360" y="2170080"/>
-            <a:ext cx="2715840" cy="2715840"/>
+            <a:ext cx="2715480" cy="2715480"/>
           </a:xfrm>
           <a:prstGeom prst="rect">
             <a:avLst/>
@@ -6456,7 +6923,7 @@
       </p:pic>
       <p:pic>
         <p:nvPicPr>
-          <p:cNvPr id="93" name=""/>
+          <p:cNvPr id="98" name=""/>
           <p:cNvPicPr/>
           <p:nvPr/>
         </p:nvPicPr>
@@ -6467,7 +6934,7 @@
         <p:spPr>
           <a:xfrm>
             <a:off x="7900920" y="2214000"/>
-            <a:ext cx="2613240" cy="2613240"/>
+            <a:ext cx="2612880" cy="2612880"/>
           </a:xfrm>
           <a:prstGeom prst="rect">
             <a:avLst/>
@@ -6480,7 +6947,7 @@
       </p:pic>
       <p:pic>
         <p:nvPicPr>
-          <p:cNvPr id="94" name=""/>
+          <p:cNvPr id="99" name=""/>
           <p:cNvPicPr/>
           <p:nvPr/>
         </p:nvPicPr>
@@ -6491,7 +6958,7 @@
         <p:spPr>
           <a:xfrm>
             <a:off x="4800600" y="2286000"/>
-            <a:ext cx="2415960" cy="2514240"/>
+            <a:ext cx="2415600" cy="2513880"/>
           </a:xfrm>
           <a:prstGeom prst="rect">
             <a:avLst/>
@@ -6534,7 +7001,7 @@
       </p:grpSpPr>
       <p:sp>
         <p:nvSpPr>
-          <p:cNvPr id="95" name="PlaceHolder 1"/>
+          <p:cNvPr id="100" name="PlaceHolder 1"/>
           <p:cNvSpPr>
             <a:spLocks noGrp="1"/>
           </p:cNvSpPr>
@@ -6545,7 +7012,7 @@
         <p:spPr>
           <a:xfrm>
             <a:off x="431280" y="1068120"/>
-            <a:ext cx="11327760" cy="5100840"/>
+            <a:ext cx="11327400" cy="5100480"/>
           </a:xfrm>
           <a:prstGeom prst="rect">
             <a:avLst/>
@@ -6582,19 +7049,7 @@
                 <a:uFillTx/>
                 <a:latin typeface="Arial"/>
               </a:rPr>
-              <a:t>Zoom: </a:t>
-            </a:r>
-            <a:r>
-              <a:rPr lang="en-SE" sz="2400" b="0" u="none" strike="noStrike">
-                <a:solidFill>
-                  <a:srgbClr val="000000"/>
-                </a:solidFill>
-                <a:effectLst/>
-                <a:uFillTx/>
-                <a:latin typeface="Arial"/>
-                <a:hlinkClick r:id="rId1"/>
-              </a:rPr>
-              <a:t>https://uu-se.zoom.us/j/63015771777?pwd=Y4lbcIadBQZxTVkmwMhX0O9zw0cEbI.1</a:t>
+              <a:t>Lunch ~12:00 every day</a:t>
             </a:r>
             <a:endParaRPr lang="en-US" sz="2400" b="0" u="none" strike="noStrike">
               <a:solidFill>
@@ -6628,7 +7083,7 @@
                 <a:uFillTx/>
                 <a:latin typeface="Arial"/>
               </a:rPr>
-              <a:t>Lunch ~12:00 every day</a:t>
+              <a:t>Coffee breaks in the morning and afternoon (exact times decided per day)</a:t>
             </a:r>
             <a:endParaRPr lang="en-US" sz="2400" b="0" u="none" strike="noStrike">
               <a:solidFill>
@@ -6662,7 +7117,7 @@
                 <a:uFillTx/>
                 <a:latin typeface="Arial"/>
               </a:rPr>
-              <a:t>Coffee breaks in the morning and afternoon (exact times decided per day)</a:t>
+              <a:t>Times in schedule may be adjusted slightly depending on breaks. Start time in the morning and after lunch is “fixed”.</a:t>
             </a:r>
             <a:endParaRPr lang="en-US" sz="2400" b="0" u="none" strike="noStrike">
               <a:solidFill>
@@ -6696,7 +7151,7 @@
                 <a:uFillTx/>
                 <a:latin typeface="Arial"/>
               </a:rPr>
-              <a:t>Times in schedule may be adjusted slightly depending on breaks. Start time in the morning and after lunch is “fixed”.</a:t>
+              <a:t>Lectures in the main zoom room</a:t>
             </a:r>
             <a:endParaRPr lang="en-US" sz="2400" b="0" u="none" strike="noStrike">
               <a:solidFill>
@@ -6730,7 +7185,7 @@
                 <a:uFillTx/>
                 <a:latin typeface="Arial"/>
               </a:rPr>
-              <a:t>Lectures in the main zoom room</a:t>
+              <a:t>Labs in breakout rooms</a:t>
             </a:r>
             <a:endParaRPr lang="en-US" sz="2400" b="0" u="none" strike="noStrike">
               <a:solidFill>
@@ -6764,40 +7219,6 @@
                 <a:uFillTx/>
                 <a:latin typeface="Arial"/>
               </a:rPr>
-              <a:t>Labs in breakout rooms</a:t>
-            </a:r>
-            <a:endParaRPr lang="en-US" sz="2400" b="0" u="none" strike="noStrike">
-              <a:solidFill>
-                <a:srgbClr val="000000"/>
-              </a:solidFill>
-              <a:effectLst/>
-              <a:uFillTx/>
-              <a:latin typeface="Arial"/>
-            </a:endParaRPr>
-          </a:p>
-          <a:p>
-            <a:pPr marL="343080" indent="-343080" defTabSz="914400">
-              <a:lnSpc>
-                <a:spcPct val="90000"/>
-              </a:lnSpc>
-              <a:spcBef>
-                <a:spcPts val="1001"/>
-              </a:spcBef>
-              <a:buClr>
-                <a:srgbClr val="181717"/>
-              </a:buClr>
-              <a:buFont typeface="Arial"/>
-              <a:buChar char="•"/>
-            </a:pPr>
-            <a:r>
-              <a:rPr lang="en-SE" sz="2400" b="0" u="none" strike="noStrike">
-                <a:solidFill>
-                  <a:srgbClr val="000000"/>
-                </a:solidFill>
-                <a:effectLst/>
-                <a:uFillTx/>
-                <a:latin typeface="Arial"/>
-              </a:rPr>
               <a:t>Please have cameras on</a:t>
             </a:r>
             <a:endParaRPr lang="en-US" sz="2400" b="0" u="none" strike="noStrike">
@@ -6813,7 +7234,7 @@
       </p:sp>
       <p:sp>
         <p:nvSpPr>
-          <p:cNvPr id="96" name="PlaceHolder 2"/>
+          <p:cNvPr id="101" name="PlaceHolder 2"/>
           <p:cNvSpPr>
             <a:spLocks noGrp="1"/>
           </p:cNvSpPr>
@@ -6824,7 +7245,7 @@
         <p:spPr>
           <a:xfrm>
             <a:off x="431280" y="321480"/>
-            <a:ext cx="11327760" cy="543960"/>
+            <a:ext cx="11327400" cy="543600"/>
           </a:xfrm>
           <a:prstGeom prst="rect">
             <a:avLst/>
@@ -6859,228 +7280,7 @@
                 <a:uFillTx/>
                 <a:latin typeface="Arial"/>
               </a:rPr>
-              <a:t>P</a:t>
-            </a:r>
-            <a:r>
-              <a:rPr lang="en-SE" sz="4000" b="1" u="none" strike="noStrike">
-                <a:solidFill>
-                  <a:schemeClr val="lt2">
-                    <a:lumMod val="10000"/>
-                  </a:schemeClr>
-                </a:solidFill>
-                <a:effectLst/>
-                <a:uFillTx/>
-                <a:latin typeface="Arial"/>
-              </a:rPr>
-              <a:t>r</a:t>
-            </a:r>
-            <a:r>
-              <a:rPr lang="en-SE" sz="4000" b="1" u="none" strike="noStrike">
-                <a:solidFill>
-                  <a:schemeClr val="lt2">
-                    <a:lumMod val="10000"/>
-                  </a:schemeClr>
-                </a:solidFill>
-                <a:effectLst/>
-                <a:uFillTx/>
-                <a:latin typeface="Arial"/>
-              </a:rPr>
-              <a:t>a</a:t>
-            </a:r>
-            <a:r>
-              <a:rPr lang="en-SE" sz="4000" b="1" u="none" strike="noStrike">
-                <a:solidFill>
-                  <a:schemeClr val="lt2">
-                    <a:lumMod val="10000"/>
-                  </a:schemeClr>
-                </a:solidFill>
-                <a:effectLst/>
-                <a:uFillTx/>
-                <a:latin typeface="Arial"/>
-              </a:rPr>
-              <a:t>c</a:t>
-            </a:r>
-            <a:r>
-              <a:rPr lang="en-SE" sz="4000" b="1" u="none" strike="noStrike">
-                <a:solidFill>
-                  <a:schemeClr val="lt2">
-                    <a:lumMod val="10000"/>
-                  </a:schemeClr>
-                </a:solidFill>
-                <a:effectLst/>
-                <a:uFillTx/>
-                <a:latin typeface="Arial"/>
-              </a:rPr>
-              <a:t>ti</a:t>
-            </a:r>
-            <a:r>
-              <a:rPr lang="en-SE" sz="4000" b="1" u="none" strike="noStrike">
-                <a:solidFill>
-                  <a:schemeClr val="lt2">
-                    <a:lumMod val="10000"/>
-                  </a:schemeClr>
-                </a:solidFill>
-                <a:effectLst/>
-                <a:uFillTx/>
-                <a:latin typeface="Arial"/>
-              </a:rPr>
-              <a:t>c</a:t>
-            </a:r>
-            <a:r>
-              <a:rPr lang="en-SE" sz="4000" b="1" u="none" strike="noStrike">
-                <a:solidFill>
-                  <a:schemeClr val="lt2">
-                    <a:lumMod val="10000"/>
-                  </a:schemeClr>
-                </a:solidFill>
-                <a:effectLst/>
-                <a:uFillTx/>
-                <a:latin typeface="Arial"/>
-              </a:rPr>
-              <a:t>a</a:t>
-            </a:r>
-            <a:r>
-              <a:rPr lang="en-SE" sz="4000" b="1" u="none" strike="noStrike">
-                <a:solidFill>
-                  <a:schemeClr val="lt2">
-                    <a:lumMod val="10000"/>
-                  </a:schemeClr>
-                </a:solidFill>
-                <a:effectLst/>
-                <a:uFillTx/>
-                <a:latin typeface="Arial"/>
-              </a:rPr>
-              <a:t>l </a:t>
-            </a:r>
-            <a:r>
-              <a:rPr lang="en-SE" sz="4000" b="1" u="none" strike="noStrike">
-                <a:solidFill>
-                  <a:schemeClr val="lt2">
-                    <a:lumMod val="10000"/>
-                  </a:schemeClr>
-                </a:solidFill>
-                <a:effectLst/>
-                <a:uFillTx/>
-                <a:latin typeface="Arial"/>
-              </a:rPr>
-              <a:t>i</a:t>
-            </a:r>
-            <a:r>
-              <a:rPr lang="en-SE" sz="4000" b="1" u="none" strike="noStrike">
-                <a:solidFill>
-                  <a:schemeClr val="lt2">
-                    <a:lumMod val="10000"/>
-                  </a:schemeClr>
-                </a:solidFill>
-                <a:effectLst/>
-                <a:uFillTx/>
-                <a:latin typeface="Arial"/>
-              </a:rPr>
-              <a:t>n</a:t>
-            </a:r>
-            <a:r>
-              <a:rPr lang="en-SE" sz="4000" b="1" u="none" strike="noStrike">
-                <a:solidFill>
-                  <a:schemeClr val="lt2">
-                    <a:lumMod val="10000"/>
-                  </a:schemeClr>
-                </a:solidFill>
-                <a:effectLst/>
-                <a:uFillTx/>
-                <a:latin typeface="Arial"/>
-              </a:rPr>
-              <a:t>f</a:t>
-            </a:r>
-            <a:r>
-              <a:rPr lang="en-SE" sz="4000" b="1" u="none" strike="noStrike">
-                <a:solidFill>
-                  <a:schemeClr val="lt2">
-                    <a:lumMod val="10000"/>
-                  </a:schemeClr>
-                </a:solidFill>
-                <a:effectLst/>
-                <a:uFillTx/>
-                <a:latin typeface="Arial"/>
-              </a:rPr>
-              <a:t>o</a:t>
-            </a:r>
-            <a:r>
-              <a:rPr lang="en-SE" sz="4000" b="1" u="none" strike="noStrike">
-                <a:solidFill>
-                  <a:schemeClr val="lt2">
-                    <a:lumMod val="10000"/>
-                  </a:schemeClr>
-                </a:solidFill>
-                <a:effectLst/>
-                <a:uFillTx/>
-                <a:latin typeface="Arial"/>
-              </a:rPr>
-              <a:t>r</a:t>
-            </a:r>
-            <a:r>
-              <a:rPr lang="en-SE" sz="4000" b="1" u="none" strike="noStrike">
-                <a:solidFill>
-                  <a:schemeClr val="lt2">
-                    <a:lumMod val="10000"/>
-                  </a:schemeClr>
-                </a:solidFill>
-                <a:effectLst/>
-                <a:uFillTx/>
-                <a:latin typeface="Arial"/>
-              </a:rPr>
-              <a:t>m</a:t>
-            </a:r>
-            <a:r>
-              <a:rPr lang="en-SE" sz="4000" b="1" u="none" strike="noStrike">
-                <a:solidFill>
-                  <a:schemeClr val="lt2">
-                    <a:lumMod val="10000"/>
-                  </a:schemeClr>
-                </a:solidFill>
-                <a:effectLst/>
-                <a:uFillTx/>
-                <a:latin typeface="Arial"/>
-              </a:rPr>
-              <a:t>a</a:t>
-            </a:r>
-            <a:r>
-              <a:rPr lang="en-SE" sz="4000" b="1" u="none" strike="noStrike">
-                <a:solidFill>
-                  <a:schemeClr val="lt2">
-                    <a:lumMod val="10000"/>
-                  </a:schemeClr>
-                </a:solidFill>
-                <a:effectLst/>
-                <a:uFillTx/>
-                <a:latin typeface="Arial"/>
-              </a:rPr>
-              <a:t>ti</a:t>
-            </a:r>
-            <a:r>
-              <a:rPr lang="en-SE" sz="4000" b="1" u="none" strike="noStrike">
-                <a:solidFill>
-                  <a:schemeClr val="lt2">
-                    <a:lumMod val="10000"/>
-                  </a:schemeClr>
-                </a:solidFill>
-                <a:effectLst/>
-                <a:uFillTx/>
-                <a:latin typeface="Arial"/>
-              </a:rPr>
-              <a:t>o</a:t>
-            </a:r>
-            <a:r>
-              <a:rPr lang="en-SE" sz="4000" b="1" u="none" strike="noStrike">
-                <a:solidFill>
-                  <a:schemeClr val="lt2">
-                    <a:lumMod val="10000"/>
-                  </a:schemeClr>
-                </a:solidFill>
-                <a:effectLst/>
-                <a:uFillTx/>
-                <a:latin typeface="Arial"/>
-              </a:rPr>
-              <a:t>n</a:t>
+              <a:t>Practical information</a:t>
             </a:r>
             <a:endParaRPr lang="en-US" sz="4000" b="0" u="none" strike="noStrike">
               <a:solidFill>
@@ -7125,7 +7325,7 @@
       </p:grpSpPr>
       <p:sp>
         <p:nvSpPr>
-          <p:cNvPr id="97" name="PlaceHolder 1"/>
+          <p:cNvPr id="102" name="PlaceHolder 1"/>
           <p:cNvSpPr>
             <a:spLocks noGrp="1"/>
           </p:cNvSpPr>
@@ -7136,7 +7336,7 @@
         <p:spPr>
           <a:xfrm>
             <a:off x="457200" y="1127880"/>
-            <a:ext cx="9121680" cy="2990520"/>
+            <a:ext cx="9121320" cy="2990160"/>
           </a:xfrm>
           <a:prstGeom prst="rect">
             <a:avLst/>
@@ -7230,7 +7430,7 @@
             <a:r>
               <a:rPr lang="en-GB" sz="2400" b="0" u="none" strike="noStrike">
                 <a:solidFill>
-                  <a:srgbClr val="000000"/>
+                  <a:srgbClr val="045b63"/>
                 </a:solidFill>
                 <a:effectLst/>
                 <a:uFillTx/>
@@ -7553,7 +7753,7 @@
       </p:sp>
       <p:sp>
         <p:nvSpPr>
-          <p:cNvPr id="98" name="PlaceHolder 2"/>
+          <p:cNvPr id="103" name="PlaceHolder 2"/>
           <p:cNvSpPr>
             <a:spLocks noGrp="1"/>
           </p:cNvSpPr>
@@ -7564,7 +7764,7 @@
         <p:spPr>
           <a:xfrm>
             <a:off x="431280" y="321480"/>
-            <a:ext cx="11327760" cy="543960"/>
+            <a:ext cx="11327400" cy="543600"/>
           </a:xfrm>
           <a:prstGeom prst="rect">
             <a:avLst/>
@@ -7644,7 +7844,7 @@
       </p:grpSpPr>
       <p:sp>
         <p:nvSpPr>
-          <p:cNvPr id="99" name="PlaceHolder 1"/>
+          <p:cNvPr id="104" name="PlaceHolder 1"/>
           <p:cNvSpPr>
             <a:spLocks noGrp="1"/>
           </p:cNvSpPr>
@@ -7655,7 +7855,7 @@
         <p:spPr>
           <a:xfrm>
             <a:off x="457200" y="1127880"/>
-            <a:ext cx="9121680" cy="2990520"/>
+            <a:ext cx="9121320" cy="2990160"/>
           </a:xfrm>
           <a:prstGeom prst="rect">
             <a:avLst/>
@@ -7929,7 +8129,7 @@
       </p:sp>
       <p:sp>
         <p:nvSpPr>
-          <p:cNvPr id="100" name="PlaceHolder 2"/>
+          <p:cNvPr id="105" name="PlaceHolder 2"/>
           <p:cNvSpPr>
             <a:spLocks noGrp="1"/>
           </p:cNvSpPr>
@@ -7940,7 +8140,7 @@
         <p:spPr>
           <a:xfrm>
             <a:off x="431280" y="321480"/>
-            <a:ext cx="11327760" cy="543960"/>
+            <a:ext cx="11327400" cy="543600"/>
           </a:xfrm>
           <a:prstGeom prst="rect">
             <a:avLst/>
@@ -8020,7 +8220,7 @@
       </p:grpSpPr>
       <p:sp>
         <p:nvSpPr>
-          <p:cNvPr id="101" name="PlaceHolder 1"/>
+          <p:cNvPr id="106" name="PlaceHolder 1"/>
           <p:cNvSpPr>
             <a:spLocks noGrp="1"/>
           </p:cNvSpPr>
@@ -8031,7 +8231,7 @@
         <p:spPr>
           <a:xfrm>
             <a:off x="431280" y="1068120"/>
-            <a:ext cx="11327760" cy="5100840"/>
+            <a:ext cx="11327400" cy="5100480"/>
           </a:xfrm>
           <a:prstGeom prst="rect">
             <a:avLst/>
@@ -8318,7 +8518,7 @@
       </p:sp>
       <p:sp>
         <p:nvSpPr>
-          <p:cNvPr id="102" name="PlaceHolder 2"/>
+          <p:cNvPr id="107" name="PlaceHolder 2"/>
           <p:cNvSpPr>
             <a:spLocks noGrp="1"/>
           </p:cNvSpPr>
@@ -8329,7 +8529,7 @@
         <p:spPr>
           <a:xfrm>
             <a:off x="431280" y="321480"/>
-            <a:ext cx="11327760" cy="543960"/>
+            <a:ext cx="11327400" cy="543600"/>
           </a:xfrm>
           <a:prstGeom prst="rect">
             <a:avLst/>
@@ -8364,59 +8564,7 @@
                 <a:uFillTx/>
                 <a:latin typeface="Arial"/>
               </a:rPr>
-              <a:t>Attend</a:t>
-            </a:r>
-            <a:r>
-              <a:rPr lang="en-SE" sz="4000" b="1" u="none" strike="noStrike">
-                <a:solidFill>
-                  <a:schemeClr val="lt2">
-                    <a:lumMod val="10000"/>
-                  </a:schemeClr>
-                </a:solidFill>
-                <a:effectLst/>
-                <a:uFillTx/>
-                <a:latin typeface="Arial"/>
-              </a:rPr>
-              <a:t>ence </a:t>
-            </a:r>
-            <a:r>
-              <a:rPr lang="en-SE" sz="4000" b="1" u="none" strike="noStrike">
-                <a:solidFill>
-                  <a:schemeClr val="lt2">
-                    <a:lumMod val="10000"/>
-                  </a:schemeClr>
-                </a:solidFill>
-                <a:effectLst/>
-                <a:uFillTx/>
-                <a:latin typeface="Arial"/>
-              </a:rPr>
-              <a:t>and </a:t>
-            </a:r>
-            <a:r>
-              <a:rPr lang="en-SE" sz="4000" b="1" u="none" strike="noStrike">
-                <a:solidFill>
-                  <a:schemeClr val="lt2">
-                    <a:lumMod val="10000"/>
-                  </a:schemeClr>
-                </a:solidFill>
-                <a:effectLst/>
-                <a:uFillTx/>
-                <a:latin typeface="Arial"/>
-              </a:rPr>
-              <a:t>certific</a:t>
-            </a:r>
-            <a:r>
-              <a:rPr lang="en-SE" sz="4000" b="1" u="none" strike="noStrike">
-                <a:solidFill>
-                  <a:schemeClr val="lt2">
-                    <a:lumMod val="10000"/>
-                  </a:schemeClr>
-                </a:solidFill>
-                <a:effectLst/>
-                <a:uFillTx/>
-                <a:latin typeface="Arial"/>
-              </a:rPr>
-              <a:t>ate</a:t>
+              <a:t>Attendence and certificate</a:t>
             </a:r>
             <a:endParaRPr lang="en-US" sz="4000" b="0" u="none" strike="noStrike">
               <a:solidFill>
@@ -8461,7 +8609,7 @@
       </p:grpSpPr>
       <p:sp>
         <p:nvSpPr>
-          <p:cNvPr id="103" name="PlaceHolder 1"/>
+          <p:cNvPr id="108" name="PlaceHolder 1"/>
           <p:cNvSpPr>
             <a:spLocks noGrp="1"/>
           </p:cNvSpPr>
@@ -8472,7 +8620,7 @@
         <p:spPr>
           <a:xfrm>
             <a:off x="1523880" y="1600200"/>
-            <a:ext cx="9142200" cy="1908000"/>
+            <a:ext cx="9141840" cy="1907640"/>
           </a:xfrm>
           <a:prstGeom prst="rect">
             <a:avLst/>
@@ -8522,7 +8670,7 @@
       </p:sp>
       <p:sp>
         <p:nvSpPr>
-          <p:cNvPr id="104" name="PlaceHolder 2"/>
+          <p:cNvPr id="109" name="PlaceHolder 2"/>
           <p:cNvSpPr>
             <a:spLocks noGrp="1"/>
           </p:cNvSpPr>
@@ -8533,7 +8681,7 @@
         <p:spPr>
           <a:xfrm>
             <a:off x="1523880" y="3602160"/>
-            <a:ext cx="9142200" cy="1653840"/>
+            <a:ext cx="9141840" cy="1653480"/>
           </a:xfrm>
           <a:prstGeom prst="rect">
             <a:avLst/>
@@ -9285,7 +9433,7 @@
 </a:theme>
 </file>
 
-<file path=ppt/theme/theme7.xml><?xml version="1.0" encoding="utf-8"?>
+<file path=ppt/theme/theme8.xml><?xml version="1.0" encoding="utf-8"?>
 <a:theme xmlns:a="http://schemas.openxmlformats.org/drawingml/2006/main" xmlns:r="http://schemas.openxmlformats.org/officeDocument/2006/relationships" name="Office Theme">
   <a:themeElements>
     <a:clrScheme name="LibreOffice">

</xml_diff>